<commit_message>
Center cMedQA2 on medical answer selection and its original candidate sets
</commit_message>
<xml_diff>
--- a/slides/datasets-in-10-minutes-cmedqa2.pptx
+++ b/slides/datasets-in-10-minutes-cmedqa2.pptx
@@ -23,7 +23,6 @@
     <p:sldId id="321" r:id="rId71"/>
     <p:sldId id="322" r:id="rId72"/>
     <p:sldId id="323" r:id="rId73"/>
-    <p:sldId id="324" r:id="rId74"/>
     <p:sldId id="325" r:id="rId75"/>
     <p:sldId id="326" r:id="rId76"/>
     <p:sldId id="327" r:id="rId77"/>
@@ -49,7 +48,6 @@
     <p:sldId id="336" r:id="rId86"/>
     <p:sldId id="337" r:id="rId87"/>
     <p:sldId id="307" r:id="rId57"/>
-    <p:sldId id="308" r:id="rId58"/>
   </p:sldIdLst>
   <p:sldSz cx="9144000" cy="5143500" type="screen16x9"/>
   <p:notesSz cx="6858000" cy="9144000"/>
@@ -12282,158 +12280,45 @@
         </p:nvSpPr>
         <p:spPr>
           <a:xfrm>
-            <a:off x="468172" y="650138"/>
-            <a:ext cx="8206740" cy="616305"/>
+            <a:off x="548640" y="2506875"/>
+            <a:ext cx="8046720" cy="585216"/>
           </a:xfrm>
         </p:spPr>
         <p:txBody>
-          <a:bodyPr wrap="square" lIns="0" rIns="0" tIns="0" bIns="0">
+          <a:bodyPr wrap="square" lIns="0" rIns="0" tIns="0" bIns="0" anchor="ctr">
             <a:noAutofit/>
           </a:bodyPr>
           <a:lstStyle/>
           <a:p>
-            <a:pPr algn="l">
+            <a:pPr algn="ctr">
               <a:lnSpc>
                 <a:spcPct val="110000"/>
               </a:lnSpc>
               <a:buNone/>
-              <a:defRPr sz="2800" b="0">
-                <a:solidFill>
-                  <a:srgbClr val="303437"/>
-                </a:solidFill>
-                <a:latin typeface="Noto Sans"/>
-              </a:defRPr>
-            </a:pPr>
-            <a:r>
-              <a:rPr sz="2800" b="1" lang="ja-JP" altLang="en-US">
-                <a:solidFill>
-                  <a:srgbClr val="303437"/>
-                </a:solidFill>
-                <a:latin typeface="Noto Sans"/>
-                <a:ea typeface="Noto Sans CJK JP"/>
-                <a:cs typeface="Noto Sans"/>
-              </a:rPr>
-              <a:t>CLEVAでは、質問と回答の二択判定に応用</a:t>
+              <a:defRPr sz="3600" b="0">
+                <a:solidFill>
+                  <a:srgbClr val="303437"/>
+                </a:solidFill>
+                <a:latin typeface="Noto Sans"/>
+              </a:defRPr>
+            </a:pPr>
+            <a:r>
+              <a:rPr sz="3600" b="1" lang="ja-JP" altLang="en-US">
+                <a:solidFill>
+                  <a:srgbClr val="303437"/>
+                </a:solidFill>
+                <a:latin typeface="Noto Sans"/>
+                <a:ea typeface="Noto Sans CJK JP"/>
+                <a:cs typeface="Noto Sans"/>
+              </a:rPr>
+              <a:t>公式データの入手と利用条件</a:t>
             </a:r>
           </a:p>
         </p:txBody>
       </p:sp>
       <p:sp>
         <p:nvSpPr>
-          <p:cNvPr id="3" name="Text Placeholder 2"/>
-          <p:cNvSpPr>
-            <a:spLocks noGrp="1"/>
-          </p:cNvSpPr>
-          <p:nvPr>
-            <p:ph type="body" idx="1"/>
-          </p:nvPr>
-        </p:nvSpPr>
-        <p:spPr>
-          <a:xfrm>
-            <a:off x="594360" y="1463040"/>
-            <a:ext cx="7955279" cy="3044952"/>
-          </a:xfrm>
-        </p:spPr>
-        <p:txBody>
-          <a:bodyPr wrap="square" tIns="91440" bIns="91440">
-            <a:noAutofit/>
-          </a:bodyPr>
-          <a:lstStyle/>
-          <a:p>
-            <a:pPr marL="457200" indent="-355600">
-              <a:lnSpc>
-                <a:spcPts val="2439"/>
-              </a:lnSpc>
-              <a:spcAft>
-                <a:spcPts val="700"/>
-              </a:spcAft>
-              <a:buSzPct val="64878"/>
-              <a:buFont typeface="Noto Sans CJK JP"/>
-              <a:buChar char="●"/>
-              <a:defRPr sz="2050" b="0">
-                <a:solidFill>
-                  <a:srgbClr val="303437"/>
-                </a:solidFill>
-                <a:latin typeface="Noto Sans"/>
-              </a:defRPr>
-            </a:pPr>
-            <a:r>
-              <a:rPr sz="2050" b="0" lang="ja-JP" altLang="en-US">
-                <a:solidFill>
-                  <a:srgbClr val="303437"/>
-                </a:solidFill>
-                <a:latin typeface="Noto Sans"/>
-                <a:ea typeface="Noto Sans CJK JP"/>
-                <a:cs typeface="Noto Sans"/>
-              </a:rPr>
-              <a:t>中国語モデルの評価基盤CLEVAは、医療QA課題の出典としてcMedQA2を採用している。</a:t>
-            </a:r>
-          </a:p>
-          <a:p>
-            <a:pPr marL="457200" indent="-355600">
-              <a:lnSpc>
-                <a:spcPts val="2439"/>
-              </a:lnSpc>
-              <a:spcAft>
-                <a:spcPts val="700"/>
-              </a:spcAft>
-              <a:buSzPct val="64878"/>
-              <a:buFont typeface="Noto Sans CJK JP"/>
-              <a:buChar char="●"/>
-              <a:defRPr sz="2050" b="0">
-                <a:solidFill>
-                  <a:srgbClr val="303437"/>
-                </a:solidFill>
-                <a:latin typeface="Noto Sans"/>
-              </a:defRPr>
-            </a:pPr>
-            <a:r>
-              <a:rPr sz="2050" b="0" lang="ja-JP" altLang="en-US">
-                <a:solidFill>
-                  <a:srgbClr val="303437"/>
-                </a:solidFill>
-                <a:latin typeface="Noto Sans"/>
-                <a:ea typeface="Noto Sans CJK JP"/>
-                <a:cs typeface="Noto Sans"/>
-              </a:rPr>
-              <a:t>HELM v0.4.0の公開例では、質問と医師の回答を提示し、正しく答えているかをA＝否、B＝是の二択で尋ねる。実例1の質問・回答に対応し、正解はBである。</a:t>
-            </a:r>
-          </a:p>
-          <a:p>
-            <a:pPr marL="457200" indent="-355600">
-              <a:lnSpc>
-                <a:spcPts val="2439"/>
-              </a:lnSpc>
-              <a:spcAft>
-                <a:spcPts val="0"/>
-              </a:spcAft>
-              <a:buSzPct val="64878"/>
-              <a:buFont typeface="Noto Sans CJK JP"/>
-              <a:buChar char="●"/>
-              <a:defRPr sz="2050" b="0">
-                <a:solidFill>
-                  <a:srgbClr val="303437"/>
-                </a:solidFill>
-                <a:latin typeface="Noto Sans"/>
-              </a:defRPr>
-            </a:pPr>
-            <a:r>
-              <a:rPr sz="2050" b="0" lang="ja-JP" altLang="en-US">
-                <a:solidFill>
-                  <a:srgbClr val="303437"/>
-                </a:solidFill>
-                <a:latin typeface="Noto Sans"/>
-                <a:ea typeface="Noto Sans CJK JP"/>
-                <a:cs typeface="Noto Sans"/>
-              </a:rPr>
-              <a:t>元データの100候補から選ぶ形式を変更した利用法である。CLEVA版の評価集合の全体とモデル別成績は、参照した公開資料では明らかになっていない。</a:t>
-            </a:r>
-          </a:p>
-        </p:txBody>
-      </p:sp>
-      <p:sp>
-        <p:nvSpPr>
-          <p:cNvPr id="4" name="Title 3"/>
+          <p:cNvPr id="3" name="Title 2"/>
           <p:cNvSpPr>
             <a:spLocks noGrp="1"/>
           </p:cNvSpPr>
@@ -12474,138 +12359,7 @@
                 <a:ea typeface="Noto Sans CJK JP"/>
                 <a:cs typeface="Noto Sans"/>
               </a:rPr>
-              <a:t>3. 評価方法と成績</a:t>
-            </a:r>
-          </a:p>
-        </p:txBody>
-      </p:sp>
-      <p:sp>
-        <p:nvSpPr>
-          <p:cNvPr id="5" name="sources"/>
-          <p:cNvSpPr txBox="1"/>
-          <p:nvPr/>
-        </p:nvSpPr>
-        <p:spPr>
-          <a:xfrm>
-            <a:off x="502920" y="4590288"/>
-            <a:ext cx="8183879" cy="530352"/>
-          </a:xfrm>
-          <a:prstGeom prst="rect">
-            <a:avLst/>
-          </a:prstGeom>
-          <a:noFill/>
-        </p:spPr>
-        <p:txBody>
-          <a:bodyPr wrap="square" lIns="0" rIns="0" tIns="0" bIns="0">
-            <a:noAutofit/>
-          </a:bodyPr>
-          <a:lstStyle/>
-          <a:p>
-            <a:pPr algn="l">
-              <a:lnSpc>
-                <a:spcPts val="940"/>
-              </a:lnSpc>
-              <a:spcBef>
-                <a:spcPts val="0"/>
-              </a:spcBef>
-              <a:spcAft>
-                <a:spcPts val="140"/>
-              </a:spcAft>
-              <a:buNone/>
-              <a:defRPr sz="810" b="0">
-                <a:solidFill>
-                  <a:srgbClr val="303437"/>
-                </a:solidFill>
-                <a:latin typeface="Noto Sans"/>
-              </a:defRPr>
-            </a:pPr>
-            <a:r>
-              <a:rPr sz="810" b="0" lang="ja-JP" altLang="en-US">
-                <a:solidFill>
-                  <a:srgbClr val="626669"/>
-                </a:solidFill>
-                <a:latin typeface="Noto Sans"/>
-                <a:ea typeface="Noto Sans CJK JP"/>
-                <a:cs typeface="Noto Sans"/>
-              </a:rPr>
-              <a:t>[1] Li et al. (2023). CLEVA: Chinese Language Models EVAluation Platform. EMNLP System Demonstrations.</a:t>
-            </a:r>
-            <a:r>
-              <a:rPr sz="810" b="0" lang="ja-JP" altLang="en-US">
-                <a:solidFill>
-                  <a:srgbClr val="626669"/>
-                </a:solidFill>
-                <a:latin typeface="Noto Sans"/>
-                <a:ea typeface="Noto Sans CJK JP"/>
-                <a:cs typeface="Noto Sans"/>
-              </a:rPr>
-              <a:t>  </a:t>
-            </a:r>
-            <a:r>
-              <a:rPr sz="810" b="0" lang="ja-JP" altLang="en-US">
-                <a:solidFill>
-                  <a:srgbClr val="626669"/>
-                </a:solidFill>
-                <a:latin typeface="Noto Sans"/>
-                <a:ea typeface="Noto Sans CJK JP"/>
-                <a:cs typeface="Noto Sans"/>
-                <a:hlinkClick r:id="rId2"/>
-              </a:rPr>
-              <a:t>https://aclanthology.org/2023.emnlp-demo.17/</a:t>
-            </a:r>
-          </a:p>
-          <a:p>
-            <a:pPr>
-              <a:lnSpc>
-                <a:spcPts val="940"/>
-              </a:lnSpc>
-              <a:spcAft>
-                <a:spcPts val="140"/>
-              </a:spcAft>
-              <a:buNone/>
-              <a:defRPr sz="810" b="0">
-                <a:solidFill>
-                  <a:srgbClr val="303437"/>
-                </a:solidFill>
-                <a:latin typeface="Noto Sans"/>
-              </a:defRPr>
-            </a:pPr>
-            <a:r>
-              <a:rPr sz="810" b="0" lang="ja-JP" altLang="en-US">
-                <a:solidFill>
-                  <a:srgbClr val="626669"/>
-                </a:solidFill>
-                <a:latin typeface="Noto Sans"/>
-                <a:ea typeface="Noto Sans CJK JP"/>
-                <a:cs typeface="Noto Sans"/>
-              </a:rPr>
-              <a:t>[2] Stanford CRFM (2023). CLEVAClosedBookQuestionAnsweringScenario and Converter. HELM v0.4.0.</a:t>
-            </a:r>
-          </a:p>
-          <a:p>
-            <a:pPr>
-              <a:lnSpc>
-                <a:spcPts val="940"/>
-              </a:lnSpc>
-              <a:buNone/>
-              <a:defRPr sz="810" b="0">
-                <a:solidFill>
-                  <a:srgbClr val="303437"/>
-                </a:solidFill>
-                <a:latin typeface="Noto Sans"/>
-              </a:defRPr>
-            </a:pPr>
-            <a:r>
-              <a:rPr sz="810" b="0" lang="ja-JP" altLang="en-US">
-                <a:solidFill>
-                  <a:srgbClr val="626669"/>
-                </a:solidFill>
-                <a:latin typeface="Noto Sans"/>
-                <a:ea typeface="Noto Sans CJK JP"/>
-                <a:cs typeface="Noto Sans"/>
-                <a:hlinkClick r:id="rId3"/>
-              </a:rPr>
-              <a:t>https://github.com/stanford-crfm/helm/blob/v0.4.0/src/helm/benchmark/scenarios/cleva_scenario.py</a:t>
+              <a:t>4. 入手と利用</a:t>
             </a:r>
           </a:p>
         </p:txBody>
@@ -12855,45 +12609,158 @@
         </p:nvSpPr>
         <p:spPr>
           <a:xfrm>
-            <a:off x="548640" y="2506875"/>
-            <a:ext cx="8046720" cy="585216"/>
+            <a:off x="468172" y="650138"/>
+            <a:ext cx="8206740" cy="616305"/>
           </a:xfrm>
         </p:spPr>
         <p:txBody>
-          <a:bodyPr wrap="square" lIns="0" rIns="0" tIns="0" bIns="0" anchor="ctr">
+          <a:bodyPr wrap="square" lIns="0" rIns="0" tIns="0" bIns="0">
             <a:noAutofit/>
           </a:bodyPr>
           <a:lstStyle/>
           <a:p>
-            <a:pPr algn="ctr">
+            <a:pPr algn="l">
               <a:lnSpc>
                 <a:spcPct val="110000"/>
               </a:lnSpc>
               <a:buNone/>
-              <a:defRPr sz="3600" b="0">
-                <a:solidFill>
-                  <a:srgbClr val="303437"/>
-                </a:solidFill>
-                <a:latin typeface="Noto Sans"/>
-              </a:defRPr>
-            </a:pPr>
-            <a:r>
-              <a:rPr sz="3600" b="1" lang="ja-JP" altLang="en-US">
-                <a:solidFill>
-                  <a:srgbClr val="303437"/>
-                </a:solidFill>
-                <a:latin typeface="Noto Sans"/>
-                <a:ea typeface="Noto Sans CJK JP"/>
-                <a:cs typeface="Noto Sans"/>
-              </a:rPr>
-              <a:t>公式データの入手と利用条件</a:t>
+              <a:defRPr sz="2800" b="0">
+                <a:solidFill>
+                  <a:srgbClr val="303437"/>
+                </a:solidFill>
+                <a:latin typeface="Noto Sans"/>
+              </a:defRPr>
+            </a:pPr>
+            <a:r>
+              <a:rPr sz="2800" b="1" lang="ja-JP" altLang="en-US">
+                <a:solidFill>
+                  <a:srgbClr val="303437"/>
+                </a:solidFill>
+                <a:latin typeface="Noto Sans"/>
+                <a:ea typeface="Noto Sans CJK JP"/>
+                <a:cs typeface="Noto Sans"/>
+              </a:rPr>
+              <a:t>質問・回答・候補は、公式リポジトリで公開</a:t>
             </a:r>
           </a:p>
         </p:txBody>
       </p:sp>
       <p:sp>
         <p:nvSpPr>
-          <p:cNvPr id="3" name="Title 2"/>
+          <p:cNvPr id="3" name="Text Placeholder 2"/>
+          <p:cNvSpPr>
+            <a:spLocks noGrp="1"/>
+          </p:cNvSpPr>
+          <p:nvPr>
+            <p:ph type="body" idx="1"/>
+          </p:nvPr>
+        </p:nvSpPr>
+        <p:spPr>
+          <a:xfrm>
+            <a:off x="594360" y="1463040"/>
+            <a:ext cx="7955279" cy="3044952"/>
+          </a:xfrm>
+        </p:spPr>
+        <p:txBody>
+          <a:bodyPr wrap="square" tIns="91440" bIns="91440">
+            <a:noAutofit/>
+          </a:bodyPr>
+          <a:lstStyle/>
+          <a:p>
+            <a:pPr marL="457200" indent="-355600">
+              <a:lnSpc>
+                <a:spcPts val="2499"/>
+              </a:lnSpc>
+              <a:spcAft>
+                <a:spcPts val="700"/>
+              </a:spcAft>
+              <a:buSzPct val="63333"/>
+              <a:buFont typeface="Noto Sans CJK JP"/>
+              <a:buChar char="●"/>
+              <a:defRPr sz="2100" b="0">
+                <a:solidFill>
+                  <a:srgbClr val="303437"/>
+                </a:solidFill>
+                <a:latin typeface="Noto Sans"/>
+              </a:defRPr>
+            </a:pPr>
+            <a:r>
+              <a:rPr sz="2100" b="0" lang="ja-JP" altLang="en-US">
+                <a:solidFill>
+                  <a:srgbClr val="303437"/>
+                </a:solidFill>
+                <a:latin typeface="Noto Sans"/>
+                <a:ea typeface="Noto Sans CJK JP"/>
+                <a:cs typeface="Noto Sans"/>
+              </a:rPr>
+              <a:t>公式GitHubリポジトリから、質問、回答、学習用の比較組、開発用候補、テスト用候補の5つのZIPを入手できる。</a:t>
+            </a:r>
+          </a:p>
+          <a:p>
+            <a:pPr marL="457200" indent="-355600">
+              <a:lnSpc>
+                <a:spcPts val="2499"/>
+              </a:lnSpc>
+              <a:spcAft>
+                <a:spcPts val="700"/>
+              </a:spcAft>
+              <a:buSzPct val="63333"/>
+              <a:buFont typeface="Noto Sans CJK JP"/>
+              <a:buChar char="●"/>
+              <a:defRPr sz="2100" b="0">
+                <a:solidFill>
+                  <a:srgbClr val="303437"/>
+                </a:solidFill>
+                <a:latin typeface="Noto Sans"/>
+              </a:defRPr>
+            </a:pPr>
+            <a:r>
+              <a:rPr sz="2100" b="0" lang="ja-JP" altLang="en-US">
+                <a:solidFill>
+                  <a:srgbClr val="303437"/>
+                </a:solidFill>
+                <a:latin typeface="Noto Sans"/>
+                <a:ea typeface="Noto Sans CJK JP"/>
+                <a:cs typeface="Noto Sans"/>
+              </a:rPr>
+              <a:t>question.csvとanswer.csvに本文があり、候補ファイルは質問IDと回答IDを結び付ける。dev/testのlabelは、元の質問に対応する回答なら1、別の質問への回答なら0である。</a:t>
+            </a:r>
+          </a:p>
+          <a:p>
+            <a:pPr marL="457200" indent="-355600">
+              <a:lnSpc>
+                <a:spcPts val="2499"/>
+              </a:lnSpc>
+              <a:spcAft>
+                <a:spcPts val="0"/>
+              </a:spcAft>
+              <a:buSzPct val="63333"/>
+              <a:buFont typeface="Noto Sans CJK JP"/>
+              <a:buChar char="●"/>
+              <a:defRPr sz="2100" b="0">
+                <a:solidFill>
+                  <a:srgbClr val="303437"/>
+                </a:solidFill>
+                <a:latin typeface="Noto Sans"/>
+              </a:defRPr>
+            </a:pPr>
+            <a:r>
+              <a:rPr sz="2100" b="0" lang="ja-JP" altLang="en-US">
+                <a:solidFill>
+                  <a:srgbClr val="303437"/>
+                </a:solidFill>
+                <a:latin typeface="Noto Sans"/>
+                <a:ea typeface="Noto Sans CJK JP"/>
+                <a:cs typeface="Noto Sans"/>
+              </a:rPr>
+              <a:t>この構成で、回答選択モデルの学習と、同じ100候補に対する比較評価を行える。</a:t>
+            </a:r>
+          </a:p>
+        </p:txBody>
+      </p:sp>
+      <p:sp>
+        <p:nvSpPr>
+          <p:cNvPr id="4" name="Title 3"/>
           <p:cNvSpPr>
             <a:spLocks noGrp="1"/>
           </p:cNvSpPr>
@@ -12935,6 +12802,83 @@
                 <a:cs typeface="Noto Sans"/>
               </a:rPr>
               <a:t>4. 入手と利用</a:t>
+            </a:r>
+          </a:p>
+        </p:txBody>
+      </p:sp>
+      <p:sp>
+        <p:nvSpPr>
+          <p:cNvPr id="5" name="sources"/>
+          <p:cNvSpPr txBox="1"/>
+          <p:nvPr/>
+        </p:nvSpPr>
+        <p:spPr>
+          <a:xfrm>
+            <a:off x="502920" y="4754880"/>
+            <a:ext cx="8183879" cy="530352"/>
+          </a:xfrm>
+          <a:prstGeom prst="rect">
+            <a:avLst/>
+          </a:prstGeom>
+          <a:noFill/>
+        </p:spPr>
+        <p:txBody>
+          <a:bodyPr wrap="square" lIns="0" rIns="0" tIns="0" bIns="0">
+            <a:noAutofit/>
+          </a:bodyPr>
+          <a:lstStyle/>
+          <a:p>
+            <a:pPr algn="l">
+              <a:lnSpc>
+                <a:spcPts val="940"/>
+              </a:lnSpc>
+              <a:spcBef>
+                <a:spcPts val="0"/>
+              </a:spcBef>
+              <a:spcAft>
+                <a:spcPts val="140"/>
+              </a:spcAft>
+              <a:buNone/>
+              <a:defRPr sz="810" b="0">
+                <a:solidFill>
+                  <a:srgbClr val="303437"/>
+                </a:solidFill>
+                <a:latin typeface="Noto Sans"/>
+              </a:defRPr>
+            </a:pPr>
+            <a:r>
+              <a:rPr sz="810" b="0" lang="ja-JP" altLang="en-US">
+                <a:solidFill>
+                  <a:srgbClr val="626669"/>
+                </a:solidFill>
+                <a:latin typeface="Noto Sans"/>
+                <a:ea typeface="Noto Sans CJK JP"/>
+                <a:cs typeface="Noto Sans"/>
+              </a:rPr>
+              <a:t>[1] Zhang et al. (n.d.). cMedQA2. GitHub (accessed 2026-10-18).</a:t>
+            </a:r>
+            <a:r>
+              <a:rPr sz="810" b="0" lang="ja-JP" altLang="en-US">
+                <a:solidFill>
+                  <a:srgbClr val="626669"/>
+                </a:solidFill>
+                <a:latin typeface="Noto Sans"/>
+                <a:ea typeface="Noto Sans CJK JP"/>
+                <a:cs typeface="Noto Sans"/>
+              </a:rPr>
+              <a:t>  </a:t>
+            </a:r>
+            <a:r>
+              <a:rPr sz="810" b="0" lang="ja-JP" altLang="en-US">
+                <a:solidFill>
+                  <a:srgbClr val="626669"/>
+                </a:solidFill>
+                <a:latin typeface="Noto Sans"/>
+                <a:ea typeface="Noto Sans CJK JP"/>
+                <a:cs typeface="Noto Sans"/>
+                <a:hlinkClick r:id="rId2"/>
+              </a:rPr>
+              <a:t>https://github.com/zhangsheng93/cMedQA2</a:t>
             </a:r>
           </a:p>
         </p:txBody>
@@ -13000,7 +12944,7 @@
                 <a:ea typeface="Noto Sans CJK JP"/>
                 <a:cs typeface="Noto Sans"/>
               </a:rPr>
-              <a:t>質問・回答・候補は、公式リポジトリで公開</a:t>
+              <a:t>データは非商用研究向けに提供されている</a:t>
             </a:r>
           </a:p>
         </p:txBody>
@@ -13053,7 +12997,7 @@
                 <a:ea typeface="Noto Sans CJK JP"/>
                 <a:cs typeface="Noto Sans"/>
               </a:rPr>
-              <a:t>公式GitHubリポジトリから、質問、回答、学習用の比較組、開発用候補、テスト用候補の5つのZIPを入手できる。</a:t>
+              <a:t>医療相談の質問と回答は、個人情報を匿名化・除去したうえで、非商用研究向けに公開されている。</a:t>
             </a:r>
           </a:p>
           <a:p>
@@ -13083,37 +13027,7 @@
                 <a:ea typeface="Noto Sans CJK JP"/>
                 <a:cs typeface="Noto Sans"/>
               </a:rPr>
-              <a:t>question.csvとanswer.csvに本文があり、候補ファイルは質問IDと回答IDを結び付ける。dev/testのlabelは、元の質問に対応する回答なら1、別の質問への回答なら0である。</a:t>
-            </a:r>
-          </a:p>
-          <a:p>
-            <a:pPr marL="457200" indent="-355600">
-              <a:lnSpc>
-                <a:spcPts val="2499"/>
-              </a:lnSpc>
-              <a:spcAft>
-                <a:spcPts val="0"/>
-              </a:spcAft>
-              <a:buSzPct val="63333"/>
-              <a:buFont typeface="Noto Sans CJK JP"/>
-              <a:buChar char="●"/>
-              <a:defRPr sz="2100" b="0">
-                <a:solidFill>
-                  <a:srgbClr val="303437"/>
-                </a:solidFill>
-                <a:latin typeface="Noto Sans"/>
-              </a:defRPr>
-            </a:pPr>
-            <a:r>
-              <a:rPr sz="2100" b="0" lang="ja-JP" altLang="en-US">
-                <a:solidFill>
-                  <a:srgbClr val="303437"/>
-                </a:solidFill>
-                <a:latin typeface="Noto Sans"/>
-                <a:ea typeface="Noto Sans CJK JP"/>
-                <a:cs typeface="Noto Sans"/>
-              </a:rPr>
-              <a:t>この構成で、回答選択モデルの学習と、同じ100候補に対する比較評価を行える。</a:t>
+              <a:t>リポジトリにはGNU GPL v3のLICENSEも置かれている。READMEの研究利用条件と、LICENSEのデータへの適用関係は明記されていない。</a:t>
             </a:r>
           </a:p>
         </p:txBody>
@@ -13215,7 +13129,7 @@
                 <a:ea typeface="Noto Sans CJK JP"/>
                 <a:cs typeface="Noto Sans"/>
               </a:rPr>
-              <a:t>[1] Zhang et al. (n.d.). cMedQA2. GitHub (accessed 2026-10-18).</a:t>
+              <a:t>[1] Zhang et al. (n.d.). cMedQA2 — README and GPL-3.0 license. GitHub (accessed 2026-10-18).</a:t>
             </a:r>
             <a:r>
               <a:rPr sz="810" b="0" lang="ja-JP" altLang="en-US">
@@ -13236,7 +13150,7 @@
                 <a:latin typeface="Noto Sans"/>
                 <a:ea typeface="Noto Sans CJK JP"/>
                 <a:cs typeface="Noto Sans"/>
-                <a:hlinkClick r:id="rId2"/>
+                <a:hlinkClick r:id="rId3"/>
               </a:rPr>
               <a:t>https://github.com/zhangsheng93/cMedQA2</a:t>
             </a:r>
@@ -13304,7 +13218,7 @@
                 <a:ea typeface="Noto Sans CJK JP"/>
                 <a:cs typeface="Noto Sans"/>
               </a:rPr>
-              <a:t>データは非商用研究向けに提供されている</a:t>
+              <a:t>医療相談に対応する回答の選択を学ぶ</a:t>
             </a:r>
           </a:p>
         </p:txBody>
@@ -13322,11 +13236,11 @@
         <p:spPr>
           <a:xfrm>
             <a:off x="594360" y="1463040"/>
-            <a:ext cx="7955279" cy="3044952"/>
+            <a:ext cx="7955279" cy="3188609"/>
           </a:xfrm>
         </p:spPr>
         <p:txBody>
-          <a:bodyPr wrap="square" tIns="91440" bIns="91440">
+          <a:bodyPr wrap="square" tIns="91440" bIns="235097">
             <a:noAutofit/>
           </a:bodyPr>
           <a:lstStyle/>
@@ -13357,7 +13271,7 @@
                 <a:ea typeface="Noto Sans CJK JP"/>
                 <a:cs typeface="Noto Sans"/>
               </a:rPr>
-              <a:t>医療相談の質問と回答は、個人情報を匿名化・除去したうえで、非商用研究向けに公開されている。</a:t>
+              <a:t>cMedQA2は、108,000件の医療質問と203,569件の対応回答を学習・評価に使う、中国語の回答選択データセットである。</a:t>
             </a:r>
           </a:p>
           <a:p>
@@ -13387,7 +13301,37 @@
                 <a:ea typeface="Noto Sans CJK JP"/>
                 <a:cs typeface="Noto Sans"/>
               </a:rPr>
-              <a:t>リポジトリにはGNU GPL v3のLICENSEも置かれている。READMEの研究利用条件と、LICENSEのデータへの適用関係は明記されていない。</a:t>
+              <a:t>学習では正負の回答を比較し、評価では100候補から回答を選ぶ。一つの質問に複数の正例があり、症状の語が似ていても別の質問への回答が負例になる。</a:t>
+            </a:r>
+          </a:p>
+          <a:p>
+            <a:pPr marL="457200" indent="-355600">
+              <a:lnSpc>
+                <a:spcPts val="2499"/>
+              </a:lnSpc>
+              <a:spcAft>
+                <a:spcPts val="0"/>
+              </a:spcAft>
+              <a:buSzPct val="63333"/>
+              <a:buFont typeface="Noto Sans CJK JP"/>
+              <a:buChar char="●"/>
+              <a:defRPr sz="2100" b="0">
+                <a:solidFill>
+                  <a:srgbClr val="303437"/>
+                </a:solidFill>
+                <a:latin typeface="Noto Sans"/>
+              </a:defRPr>
+            </a:pPr>
+            <a:r>
+              <a:rPr sz="2100" b="0" lang="ja-JP" altLang="en-US">
+                <a:solidFill>
+                  <a:srgbClr val="303437"/>
+                </a:solidFill>
+                <a:latin typeface="Noto Sans"/>
+                <a:ea typeface="Noto Sans CJK JP"/>
+                <a:cs typeface="Noto Sans"/>
+              </a:rPr>
+              <a:t>ACC@1は、正例を最上位に選べた質問の割合を測る。元データの特徴を生かした回答選択の研究に、非商用研究の条件で利用できる。</a:t>
             </a:r>
           </a:p>
         </p:txBody>
@@ -13489,8 +13433,22 @@
                 <a:ea typeface="Noto Sans CJK JP"/>
                 <a:cs typeface="Noto Sans"/>
               </a:rPr>
-              <a:t>[1] Zhang et al. (n.d.). cMedQA2 — README and GPL-3.0 license. GitHub (accessed 2026-10-18).</a:t>
-            </a:r>
+              <a:t>[1] Zhang et al. (2018). Multi-Scale Attentive Interaction Networks for Chinese Medical Question Answer Selection. IEEE Access 6, 74061–74071.</a:t>
+            </a:r>
+          </a:p>
+          <a:p>
+            <a:pPr>
+              <a:lnSpc>
+                <a:spcPts val="940"/>
+              </a:lnSpc>
+              <a:buNone/>
+              <a:defRPr sz="810" b="0">
+                <a:solidFill>
+                  <a:srgbClr val="303437"/>
+                </a:solidFill>
+                <a:latin typeface="Noto Sans"/>
+              </a:defRPr>
+            </a:pPr>
             <a:r>
               <a:rPr sz="810" b="0" lang="ja-JP" altLang="en-US">
                 <a:solidFill>
@@ -13499,20 +13457,9 @@
                 <a:latin typeface="Noto Sans"/>
                 <a:ea typeface="Noto Sans CJK JP"/>
                 <a:cs typeface="Noto Sans"/>
-              </a:rPr>
-              <a:t>  </a:t>
-            </a:r>
-            <a:r>
-              <a:rPr sz="810" b="0" lang="ja-JP" altLang="en-US">
-                <a:solidFill>
-                  <a:srgbClr val="626669"/>
-                </a:solidFill>
-                <a:latin typeface="Noto Sans"/>
-                <a:ea typeface="Noto Sans CJK JP"/>
-                <a:cs typeface="Noto Sans"/>
-                <a:hlinkClick r:id="rId3"/>
-              </a:rPr>
-              <a:t>https://github.com/zhangsheng93/cMedQA2</a:t>
+                <a:hlinkClick r:id="rId2"/>
+              </a:rPr>
+              <a:t>https://doi.org/10.1109/ACCESS.2018.2883637</a:t>
             </a:r>
           </a:p>
         </p:txBody>
@@ -13547,158 +13494,45 @@
         </p:nvSpPr>
         <p:spPr>
           <a:xfrm>
-            <a:off x="468172" y="650138"/>
-            <a:ext cx="8206740" cy="616305"/>
+            <a:off x="548640" y="2484835"/>
+            <a:ext cx="8046720" cy="674863"/>
           </a:xfrm>
         </p:spPr>
         <p:txBody>
-          <a:bodyPr wrap="square" lIns="0" rIns="0" tIns="0" bIns="0">
+          <a:bodyPr wrap="square" lIns="0" rIns="0" tIns="0" bIns="89647" anchor="ctr">
             <a:noAutofit/>
           </a:bodyPr>
           <a:lstStyle/>
           <a:p>
-            <a:pPr algn="l">
+            <a:pPr algn="ctr">
               <a:lnSpc>
                 <a:spcPct val="110000"/>
               </a:lnSpc>
               <a:buNone/>
-              <a:defRPr sz="2800" b="0">
-                <a:solidFill>
-                  <a:srgbClr val="303437"/>
-                </a:solidFill>
-                <a:latin typeface="Noto Sans"/>
-              </a:defRPr>
-            </a:pPr>
-            <a:r>
-              <a:rPr sz="2800" b="1" lang="ja-JP" altLang="en-US">
-                <a:solidFill>
-                  <a:srgbClr val="303437"/>
-                </a:solidFill>
-                <a:latin typeface="Noto Sans"/>
-                <a:ea typeface="Noto Sans CJK JP"/>
-                <a:cs typeface="Noto Sans"/>
-              </a:rPr>
-              <a:t>医療相談に対応する回答の選択を学ぶ</a:t>
+              <a:defRPr sz="3600" b="0">
+                <a:solidFill>
+                  <a:srgbClr val="303437"/>
+                </a:solidFill>
+                <a:latin typeface="Noto Sans"/>
+              </a:defRPr>
+            </a:pPr>
+            <a:r>
+              <a:rPr sz="3600" b="1" lang="ja-JP" altLang="en-US">
+                <a:solidFill>
+                  <a:srgbClr val="303437"/>
+                </a:solidFill>
+                <a:latin typeface="Noto Sans"/>
+                <a:ea typeface="Noto Sans CJK JP"/>
+                <a:cs typeface="Noto Sans"/>
+              </a:rPr>
+              <a:t>Appendix</a:t>
             </a:r>
           </a:p>
         </p:txBody>
       </p:sp>
       <p:sp>
         <p:nvSpPr>
-          <p:cNvPr id="3" name="Text Placeholder 2"/>
-          <p:cNvSpPr>
-            <a:spLocks noGrp="1"/>
-          </p:cNvSpPr>
-          <p:nvPr>
-            <p:ph type="body" idx="1"/>
-          </p:nvPr>
-        </p:nvSpPr>
-        <p:spPr>
-          <a:xfrm>
-            <a:off x="594360" y="1463040"/>
-            <a:ext cx="7955279" cy="3188609"/>
-          </a:xfrm>
-        </p:spPr>
-        <p:txBody>
-          <a:bodyPr wrap="square" tIns="91440" bIns="235097">
-            <a:noAutofit/>
-          </a:bodyPr>
-          <a:lstStyle/>
-          <a:p>
-            <a:pPr marL="457200" indent="-355600">
-              <a:lnSpc>
-                <a:spcPts val="2499"/>
-              </a:lnSpc>
-              <a:spcAft>
-                <a:spcPts val="700"/>
-              </a:spcAft>
-              <a:buSzPct val="63333"/>
-              <a:buFont typeface="Noto Sans CJK JP"/>
-              <a:buChar char="●"/>
-              <a:defRPr sz="2100" b="0">
-                <a:solidFill>
-                  <a:srgbClr val="303437"/>
-                </a:solidFill>
-                <a:latin typeface="Noto Sans"/>
-              </a:defRPr>
-            </a:pPr>
-            <a:r>
-              <a:rPr sz="2100" b="0" lang="ja-JP" altLang="en-US">
-                <a:solidFill>
-                  <a:srgbClr val="303437"/>
-                </a:solidFill>
-                <a:latin typeface="Noto Sans"/>
-                <a:ea typeface="Noto Sans CJK JP"/>
-                <a:cs typeface="Noto Sans"/>
-              </a:rPr>
-              <a:t>cMedQA2は、108,000件の医療質問と203,569件の対応回答を学習・評価に使う、中国語の回答選択データセットである。</a:t>
-            </a:r>
-          </a:p>
-          <a:p>
-            <a:pPr marL="457200" indent="-355600">
-              <a:lnSpc>
-                <a:spcPts val="2499"/>
-              </a:lnSpc>
-              <a:spcAft>
-                <a:spcPts val="700"/>
-              </a:spcAft>
-              <a:buSzPct val="63333"/>
-              <a:buFont typeface="Noto Sans CJK JP"/>
-              <a:buChar char="●"/>
-              <a:defRPr sz="2100" b="0">
-                <a:solidFill>
-                  <a:srgbClr val="303437"/>
-                </a:solidFill>
-                <a:latin typeface="Noto Sans"/>
-              </a:defRPr>
-            </a:pPr>
-            <a:r>
-              <a:rPr sz="2100" b="0" lang="ja-JP" altLang="en-US">
-                <a:solidFill>
-                  <a:srgbClr val="303437"/>
-                </a:solidFill>
-                <a:latin typeface="Noto Sans"/>
-                <a:ea typeface="Noto Sans CJK JP"/>
-                <a:cs typeface="Noto Sans"/>
-              </a:rPr>
-              <a:t>学習では正負の回答を比較し、評価では100候補から回答を選ぶ。一つの質問に複数の正例があり、症状の語が似ていても別の質問への回答が負例になる。</a:t>
-            </a:r>
-          </a:p>
-          <a:p>
-            <a:pPr marL="457200" indent="-355600">
-              <a:lnSpc>
-                <a:spcPts val="2499"/>
-              </a:lnSpc>
-              <a:spcAft>
-                <a:spcPts val="0"/>
-              </a:spcAft>
-              <a:buSzPct val="63333"/>
-              <a:buFont typeface="Noto Sans CJK JP"/>
-              <a:buChar char="●"/>
-              <a:defRPr sz="2100" b="0">
-                <a:solidFill>
-                  <a:srgbClr val="303437"/>
-                </a:solidFill>
-                <a:latin typeface="Noto Sans"/>
-              </a:defRPr>
-            </a:pPr>
-            <a:r>
-              <a:rPr sz="2100" b="0" lang="ja-JP" altLang="en-US">
-                <a:solidFill>
-                  <a:srgbClr val="303437"/>
-                </a:solidFill>
-                <a:latin typeface="Noto Sans"/>
-                <a:ea typeface="Noto Sans CJK JP"/>
-                <a:cs typeface="Noto Sans"/>
-              </a:rPr>
-              <a:t>ACC@1は、正例を最上位に選べた質問の割合を測る。元データの特徴を生かした回答選択の研究に、非商用研究の条件で利用できる。</a:t>
-            </a:r>
-          </a:p>
-        </p:txBody>
-      </p:sp>
-      <p:sp>
-        <p:nvSpPr>
-          <p:cNvPr id="4" name="Title 3"/>
+          <p:cNvPr id="3" name="Title 2"/>
           <p:cNvSpPr>
             <a:spLocks noGrp="1"/>
           </p:cNvSpPr>
@@ -13739,87 +13573,7 @@
                 <a:ea typeface="Noto Sans CJK JP"/>
                 <a:cs typeface="Noto Sans"/>
               </a:rPr>
-              <a:t>4. 入手と利用</a:t>
-            </a:r>
-          </a:p>
-        </p:txBody>
-      </p:sp>
-      <p:sp>
-        <p:nvSpPr>
-          <p:cNvPr id="5" name="sources"/>
-          <p:cNvSpPr txBox="1"/>
-          <p:nvPr/>
-        </p:nvSpPr>
-        <p:spPr>
-          <a:xfrm>
-            <a:off x="502920" y="4754880"/>
-            <a:ext cx="8183879" cy="530352"/>
-          </a:xfrm>
-          <a:prstGeom prst="rect">
-            <a:avLst/>
-          </a:prstGeom>
-          <a:noFill/>
-        </p:spPr>
-        <p:txBody>
-          <a:bodyPr wrap="square" lIns="0" rIns="0" tIns="0" bIns="0">
-            <a:noAutofit/>
-          </a:bodyPr>
-          <a:lstStyle/>
-          <a:p>
-            <a:pPr algn="l">
-              <a:lnSpc>
-                <a:spcPts val="940"/>
-              </a:lnSpc>
-              <a:spcBef>
-                <a:spcPts val="0"/>
-              </a:spcBef>
-              <a:spcAft>
-                <a:spcPts val="140"/>
-              </a:spcAft>
-              <a:buNone/>
-              <a:defRPr sz="810" b="0">
-                <a:solidFill>
-                  <a:srgbClr val="303437"/>
-                </a:solidFill>
-                <a:latin typeface="Noto Sans"/>
-              </a:defRPr>
-            </a:pPr>
-            <a:r>
-              <a:rPr sz="810" b="0" lang="ja-JP" altLang="en-US">
-                <a:solidFill>
-                  <a:srgbClr val="626669"/>
-                </a:solidFill>
-                <a:latin typeface="Noto Sans"/>
-                <a:ea typeface="Noto Sans CJK JP"/>
-                <a:cs typeface="Noto Sans"/>
-              </a:rPr>
-              <a:t>[1] Zhang et al. (2018). Multi-Scale Attentive Interaction Networks for Chinese Medical Question Answer Selection. IEEE Access 6, 74061–74071.</a:t>
-            </a:r>
-          </a:p>
-          <a:p>
-            <a:pPr>
-              <a:lnSpc>
-                <a:spcPts val="940"/>
-              </a:lnSpc>
-              <a:buNone/>
-              <a:defRPr sz="810" b="0">
-                <a:solidFill>
-                  <a:srgbClr val="303437"/>
-                </a:solidFill>
-                <a:latin typeface="Noto Sans"/>
-              </a:defRPr>
-            </a:pPr>
-            <a:r>
-              <a:rPr sz="810" b="0" lang="ja-JP" altLang="en-US">
-                <a:solidFill>
-                  <a:srgbClr val="626669"/>
-                </a:solidFill>
-                <a:latin typeface="Noto Sans"/>
-                <a:ea typeface="Noto Sans CJK JP"/>
-                <a:cs typeface="Noto Sans"/>
-                <a:hlinkClick r:id="rId2"/>
-              </a:rPr>
-              <a:t>https://doi.org/10.1109/ACCESS.2018.2883637</a:t>
+              <a:t>Appendix</a:t>
             </a:r>
           </a:p>
         </p:txBody>
@@ -13854,45 +13608,158 @@
         </p:nvSpPr>
         <p:spPr>
           <a:xfrm>
-            <a:off x="548640" y="2484835"/>
-            <a:ext cx="8046720" cy="674863"/>
+            <a:off x="468172" y="650138"/>
+            <a:ext cx="8206740" cy="616305"/>
           </a:xfrm>
         </p:spPr>
         <p:txBody>
-          <a:bodyPr wrap="square" lIns="0" rIns="0" tIns="0" bIns="89647" anchor="ctr">
+          <a:bodyPr wrap="square" lIns="0" rIns="0" tIns="0" bIns="0">
             <a:noAutofit/>
           </a:bodyPr>
           <a:lstStyle/>
           <a:p>
-            <a:pPr algn="ctr">
+            <a:pPr algn="l">
               <a:lnSpc>
                 <a:spcPct val="110000"/>
               </a:lnSpc>
               <a:buNone/>
-              <a:defRPr sz="3600" b="0">
-                <a:solidFill>
-                  <a:srgbClr val="303437"/>
-                </a:solidFill>
-                <a:latin typeface="Noto Sans"/>
-              </a:defRPr>
-            </a:pPr>
-            <a:r>
-              <a:rPr sz="3600" b="1" lang="ja-JP" altLang="en-US">
-                <a:solidFill>
-                  <a:srgbClr val="303437"/>
-                </a:solidFill>
-                <a:latin typeface="Noto Sans"/>
-                <a:ea typeface="Noto Sans CJK JP"/>
-                <a:cs typeface="Noto Sans"/>
-              </a:rPr>
-              <a:t>Appendix</a:t>
+              <a:defRPr sz="2800" b="0">
+                <a:solidFill>
+                  <a:srgbClr val="303437"/>
+                </a:solidFill>
+                <a:latin typeface="Noto Sans"/>
+              </a:defRPr>
+            </a:pPr>
+            <a:r>
+              <a:rPr sz="2800" b="1" lang="ja-JP" altLang="en-US">
+                <a:solidFill>
+                  <a:srgbClr val="303437"/>
+                </a:solidFill>
+                <a:latin typeface="Noto Sans"/>
+                <a:ea typeface="Noto Sans CJK JP"/>
+                <a:cs typeface="Noto Sans"/>
+              </a:rPr>
+              <a:t/>
             </a:r>
           </a:p>
         </p:txBody>
       </p:sp>
       <p:sp>
         <p:nvSpPr>
-          <p:cNvPr id="3" name="Title 2"/>
+          <p:cNvPr id="3" name="Text Placeholder 2"/>
+          <p:cNvSpPr>
+            <a:spLocks noGrp="1"/>
+          </p:cNvSpPr>
+          <p:nvPr>
+            <p:ph type="body" idx="1"/>
+          </p:nvPr>
+        </p:nvSpPr>
+        <p:spPr>
+          <a:xfrm>
+            <a:off x="640080" y="1972511"/>
+            <a:ext cx="7863840" cy="1744980"/>
+          </a:xfrm>
+        </p:spPr>
+        <p:txBody>
+          <a:bodyPr lIns="0" rIns="0" tIns="0" bIns="0">
+            <a:noAutofit/>
+          </a:bodyPr>
+          <a:lstStyle/>
+          <a:p>
+            <a:pPr marL="457200" indent="-457200">
+              <a:lnSpc>
+                <a:spcPts val="3660"/>
+              </a:lnSpc>
+              <a:spcAft>
+                <a:spcPts val="1200"/>
+              </a:spcAft>
+              <a:buSzPct val="100000"/>
+              <a:buFont typeface="Noto Sans CJK JP"/>
+              <a:buAutoNum type="arabicPeriod" startAt="1"/>
+              <a:defRPr sz="3000" b="1">
+                <a:solidFill>
+                  <a:srgbClr val="303437"/>
+                </a:solidFill>
+                <a:latin typeface="Noto Sans"/>
+              </a:defRPr>
+            </a:pPr>
+            <a:r>
+              <a:rPr sz="3000" b="1" lang="ja-JP" altLang="en-US">
+                <a:solidFill>
+                  <a:srgbClr val="303437"/>
+                </a:solidFill>
+                <a:latin typeface="Noto Sans"/>
+                <a:ea typeface="Noto Sans CJK JP"/>
+                <a:cs typeface="Noto Sans"/>
+              </a:rPr>
+              <a:t>追加の医療相談例</a:t>
+            </a:r>
+          </a:p>
+          <a:p>
+            <a:pPr marL="457200" indent="-457200">
+              <a:lnSpc>
+                <a:spcPts val="3660"/>
+              </a:lnSpc>
+              <a:spcAft>
+                <a:spcPts val="1200"/>
+              </a:spcAft>
+              <a:buSzPct val="100000"/>
+              <a:buFont typeface="Noto Sans CJK JP"/>
+              <a:buAutoNum type="arabicPeriod" startAt="2"/>
+              <a:defRPr sz="3000" b="1">
+                <a:solidFill>
+                  <a:srgbClr val="303437"/>
+                </a:solidFill>
+                <a:latin typeface="Noto Sans"/>
+              </a:defRPr>
+            </a:pPr>
+            <a:r>
+              <a:rPr sz="3000" b="1" lang="ja-JP" altLang="en-US">
+                <a:solidFill>
+                  <a:srgbClr val="303437"/>
+                </a:solidFill>
+                <a:latin typeface="Noto Sans"/>
+                <a:ea typeface="Noto Sans CJK JP"/>
+                <a:cs typeface="Noto Sans"/>
+              </a:rPr>
+              <a:t>データ利用の補足</a:t>
+            </a:r>
+          </a:p>
+          <a:p>
+            <a:pPr marL="457200" indent="-457200">
+              <a:lnSpc>
+                <a:spcPts val="3660"/>
+              </a:lnSpc>
+              <a:spcAft>
+                <a:spcPts val="0"/>
+              </a:spcAft>
+              <a:buSzPct val="100000"/>
+              <a:buFont typeface="Noto Sans CJK JP"/>
+              <a:buAutoNum type="arabicPeriod" startAt="3"/>
+              <a:defRPr sz="3000" b="1">
+                <a:solidFill>
+                  <a:srgbClr val="303437"/>
+                </a:solidFill>
+                <a:latin typeface="Noto Sans"/>
+              </a:defRPr>
+            </a:pPr>
+            <a:r>
+              <a:rPr sz="3000" b="1" lang="ja-JP" altLang="en-US">
+                <a:solidFill>
+                  <a:srgbClr val="303437"/>
+                </a:solidFill>
+                <a:latin typeface="Noto Sans"/>
+                <a:ea typeface="Noto Sans CJK JP"/>
+                <a:cs typeface="Noto Sans"/>
+              </a:rPr>
+              <a:t>参考文献</a:t>
+            </a:r>
+          </a:p>
+        </p:txBody>
+      </p:sp>
+      <p:sp>
+        <p:nvSpPr>
+          <p:cNvPr id="4" name="Title 3"/>
           <p:cNvSpPr>
             <a:spLocks noGrp="1"/>
           </p:cNvSpPr>
@@ -13933,7 +13800,7 @@
                 <a:ea typeface="Noto Sans CJK JP"/>
                 <a:cs typeface="Noto Sans"/>
               </a:rPr>
-              <a:t>Appendix</a:t>
+              <a:t>Appendix: 目次</a:t>
             </a:r>
           </a:p>
         </p:txBody>
@@ -13968,233 +13835,6 @@
         </p:nvSpPr>
         <p:spPr>
           <a:xfrm>
-            <a:off x="468172" y="650138"/>
-            <a:ext cx="8206740" cy="616305"/>
-          </a:xfrm>
-        </p:spPr>
-        <p:txBody>
-          <a:bodyPr wrap="square" lIns="0" rIns="0" tIns="0" bIns="0">
-            <a:noAutofit/>
-          </a:bodyPr>
-          <a:lstStyle/>
-          <a:p>
-            <a:pPr algn="l">
-              <a:lnSpc>
-                <a:spcPct val="110000"/>
-              </a:lnSpc>
-              <a:buNone/>
-              <a:defRPr sz="2800" b="0">
-                <a:solidFill>
-                  <a:srgbClr val="303437"/>
-                </a:solidFill>
-                <a:latin typeface="Noto Sans"/>
-              </a:defRPr>
-            </a:pPr>
-            <a:r>
-              <a:rPr sz="2800" b="1" lang="ja-JP" altLang="en-US">
-                <a:solidFill>
-                  <a:srgbClr val="303437"/>
-                </a:solidFill>
-                <a:latin typeface="Noto Sans"/>
-                <a:ea typeface="Noto Sans CJK JP"/>
-                <a:cs typeface="Noto Sans"/>
-              </a:rPr>
-              <a:t/>
-            </a:r>
-          </a:p>
-        </p:txBody>
-      </p:sp>
-      <p:sp>
-        <p:nvSpPr>
-          <p:cNvPr id="3" name="Text Placeholder 2"/>
-          <p:cNvSpPr>
-            <a:spLocks noGrp="1"/>
-          </p:cNvSpPr>
-          <p:nvPr>
-            <p:ph type="body" idx="1"/>
-          </p:nvPr>
-        </p:nvSpPr>
-        <p:spPr>
-          <a:xfrm>
-            <a:off x="640080" y="1972511"/>
-            <a:ext cx="7863840" cy="1744980"/>
-          </a:xfrm>
-        </p:spPr>
-        <p:txBody>
-          <a:bodyPr lIns="0" rIns="0" tIns="0" bIns="0">
-            <a:noAutofit/>
-          </a:bodyPr>
-          <a:lstStyle/>
-          <a:p>
-            <a:pPr marL="457200" indent="-457200">
-              <a:lnSpc>
-                <a:spcPts val="3660"/>
-              </a:lnSpc>
-              <a:spcAft>
-                <a:spcPts val="1200"/>
-              </a:spcAft>
-              <a:buSzPct val="100000"/>
-              <a:buFont typeface="Noto Sans CJK JP"/>
-              <a:buAutoNum type="arabicPeriod" startAt="1"/>
-              <a:defRPr sz="3000" b="1">
-                <a:solidFill>
-                  <a:srgbClr val="303437"/>
-                </a:solidFill>
-                <a:latin typeface="Noto Sans"/>
-              </a:defRPr>
-            </a:pPr>
-            <a:r>
-              <a:rPr sz="3000" b="1" lang="ja-JP" altLang="en-US">
-                <a:solidFill>
-                  <a:srgbClr val="303437"/>
-                </a:solidFill>
-                <a:latin typeface="Noto Sans"/>
-                <a:ea typeface="Noto Sans CJK JP"/>
-                <a:cs typeface="Noto Sans"/>
-              </a:rPr>
-              <a:t>追加の医療相談例</a:t>
-            </a:r>
-          </a:p>
-          <a:p>
-            <a:pPr marL="457200" indent="-457200">
-              <a:lnSpc>
-                <a:spcPts val="3660"/>
-              </a:lnSpc>
-              <a:spcAft>
-                <a:spcPts val="1200"/>
-              </a:spcAft>
-              <a:buSzPct val="100000"/>
-              <a:buFont typeface="Noto Sans CJK JP"/>
-              <a:buAutoNum type="arabicPeriod" startAt="2"/>
-              <a:defRPr sz="3000" b="1">
-                <a:solidFill>
-                  <a:srgbClr val="303437"/>
-                </a:solidFill>
-                <a:latin typeface="Noto Sans"/>
-              </a:defRPr>
-            </a:pPr>
-            <a:r>
-              <a:rPr sz="3000" b="1" lang="ja-JP" altLang="en-US">
-                <a:solidFill>
-                  <a:srgbClr val="303437"/>
-                </a:solidFill>
-                <a:latin typeface="Noto Sans"/>
-                <a:ea typeface="Noto Sans CJK JP"/>
-                <a:cs typeface="Noto Sans"/>
-              </a:rPr>
-              <a:t>データ利用の補足</a:t>
-            </a:r>
-          </a:p>
-          <a:p>
-            <a:pPr marL="457200" indent="-457200">
-              <a:lnSpc>
-                <a:spcPts val="3660"/>
-              </a:lnSpc>
-              <a:spcAft>
-                <a:spcPts val="0"/>
-              </a:spcAft>
-              <a:buSzPct val="100000"/>
-              <a:buFont typeface="Noto Sans CJK JP"/>
-              <a:buAutoNum type="arabicPeriod" startAt="3"/>
-              <a:defRPr sz="3000" b="1">
-                <a:solidFill>
-                  <a:srgbClr val="303437"/>
-                </a:solidFill>
-                <a:latin typeface="Noto Sans"/>
-              </a:defRPr>
-            </a:pPr>
-            <a:r>
-              <a:rPr sz="3000" b="1" lang="ja-JP" altLang="en-US">
-                <a:solidFill>
-                  <a:srgbClr val="303437"/>
-                </a:solidFill>
-                <a:latin typeface="Noto Sans"/>
-                <a:ea typeface="Noto Sans CJK JP"/>
-                <a:cs typeface="Noto Sans"/>
-              </a:rPr>
-              <a:t>参考文献</a:t>
-            </a:r>
-          </a:p>
-        </p:txBody>
-      </p:sp>
-      <p:sp>
-        <p:nvSpPr>
-          <p:cNvPr id="4" name="Title 3"/>
-          <p:cNvSpPr>
-            <a:spLocks noGrp="1"/>
-          </p:cNvSpPr>
-          <p:nvPr>
-            <p:ph type="title" idx="2"/>
-          </p:nvPr>
-        </p:nvSpPr>
-        <p:spPr>
-          <a:xfrm>
-            <a:off x="75895" y="0"/>
-            <a:ext cx="8115300" cy="480060"/>
-          </a:xfrm>
-        </p:spPr>
-        <p:txBody>
-          <a:bodyPr wrap="square" lIns="0" rIns="0" tIns="0" bIns="0" anchor="ctr">
-            <a:noAutofit/>
-          </a:bodyPr>
-          <a:lstStyle/>
-          <a:p>
-            <a:pPr algn="l">
-              <a:lnSpc>
-                <a:spcPct val="110000"/>
-              </a:lnSpc>
-              <a:buNone/>
-              <a:defRPr sz="1400" b="0">
-                <a:solidFill>
-                  <a:srgbClr val="303437"/>
-                </a:solidFill>
-                <a:latin typeface="Noto Sans"/>
-              </a:defRPr>
-            </a:pPr>
-            <a:r>
-              <a:rPr sz="1400" b="1" lang="ja-JP" altLang="en-US">
-                <a:solidFill>
-                  <a:srgbClr val="FFFEF8"/>
-                </a:solidFill>
-                <a:latin typeface="Noto Sans"/>
-                <a:ea typeface="Noto Sans CJK JP"/>
-                <a:cs typeface="Noto Sans"/>
-              </a:rPr>
-              <a:t>Appendix: 目次</a:t>
-            </a:r>
-          </a:p>
-        </p:txBody>
-      </p:sp>
-    </p:spTree>
-  </p:cSld>
-  <p:clrMapOvr>
-    <a:masterClrMapping/>
-  </p:clrMapOvr>
-</p:sld>
-</file>
-
-<file path=ppt/slides/slide26.xml><?xml version="1.0" encoding="utf-8"?>
-<p:sld xmlns:a="http://schemas.openxmlformats.org/drawingml/2006/main" xmlns:p="http://schemas.openxmlformats.org/presentationml/2006/main" xmlns:r="http://schemas.openxmlformats.org/officeDocument/2006/relationships">
-  <p:cSld>
-    <p:spTree>
-      <p:nvGrpSpPr>
-        <p:cNvPr id="1" name=""/>
-        <p:cNvGrpSpPr/>
-        <p:nvPr/>
-      </p:nvGrpSpPr>
-      <p:grpSpPr/>
-      <p:sp>
-        <p:nvSpPr>
-          <p:cNvPr id="2" name="Title 1"/>
-          <p:cNvSpPr>
-            <a:spLocks noGrp="1"/>
-          </p:cNvSpPr>
-          <p:nvPr>
-            <p:ph type="title"/>
-          </p:nvPr>
-        </p:nvSpPr>
-        <p:spPr>
-          <a:xfrm>
             <a:off x="548640" y="2506875"/>
             <a:ext cx="8046720" cy="585216"/>
           </a:xfrm>
@@ -14287,7 +13927,7 @@
 </p:sld>
 </file>
 
-<file path=ppt/slides/slide27.xml><?xml version="1.0" encoding="utf-8"?>
+<file path=ppt/slides/slide26.xml><?xml version="1.0" encoding="utf-8"?>
 <p:sld xmlns:a="http://schemas.openxmlformats.org/drawingml/2006/main" xmlns:p="http://schemas.openxmlformats.org/presentationml/2006/main" xmlns:r="http://schemas.openxmlformats.org/officeDocument/2006/relationships">
   <p:cSld>
     <p:spTree>
@@ -14850,7 +14490,7 @@
 </p:sld>
 </file>
 
-<file path=ppt/slides/slide28.xml><?xml version="1.0" encoding="utf-8"?>
+<file path=ppt/slides/slide27.xml><?xml version="1.0" encoding="utf-8"?>
 <p:sld xmlns:a="http://schemas.openxmlformats.org/drawingml/2006/main" xmlns:p="http://schemas.openxmlformats.org/presentationml/2006/main" xmlns:r="http://schemas.openxmlformats.org/officeDocument/2006/relationships">
   <p:cSld>
     <p:spTree>
@@ -15413,7 +15053,7 @@
 </p:sld>
 </file>
 
-<file path=ppt/slides/slide29.xml><?xml version="1.0" encoding="utf-8"?>
+<file path=ppt/slides/slide28.xml><?xml version="1.0" encoding="utf-8"?>
 <p:sld xmlns:a="http://schemas.openxmlformats.org/drawingml/2006/main" xmlns:p="http://schemas.openxmlformats.org/presentationml/2006/main" xmlns:r="http://schemas.openxmlformats.org/officeDocument/2006/relationships">
   <p:cSld>
     <p:spTree>
@@ -15976,264 +15616,7 @@
 </p:sld>
 </file>
 
-<file path=ppt/slides/slide3.xml><?xml version="1.0" encoding="utf-8"?>
-<p:sld xmlns:a="http://schemas.openxmlformats.org/drawingml/2006/main" xmlns:p="http://schemas.openxmlformats.org/presentationml/2006/main" xmlns:r="http://schemas.openxmlformats.org/officeDocument/2006/relationships">
-  <p:cSld>
-    <p:spTree>
-      <p:nvGrpSpPr>
-        <p:cNvPr id="1" name=""/>
-        <p:cNvGrpSpPr/>
-        <p:nvPr/>
-      </p:nvGrpSpPr>
-      <p:grpSpPr/>
-      <p:sp>
-        <p:nvSpPr>
-          <p:cNvPr id="2" name="Title 1"/>
-          <p:cNvSpPr>
-            <a:spLocks noGrp="1"/>
-          </p:cNvSpPr>
-          <p:nvPr>
-            <p:ph type="title"/>
-          </p:nvPr>
-        </p:nvSpPr>
-        <p:spPr>
-          <a:xfrm>
-            <a:off x="468172" y="650138"/>
-            <a:ext cx="8206740" cy="616305"/>
-          </a:xfrm>
-        </p:spPr>
-        <p:txBody>
-          <a:bodyPr wrap="square" lIns="0" rIns="0" tIns="0" bIns="0">
-            <a:noAutofit/>
-          </a:bodyPr>
-          <a:lstStyle/>
-          <a:p>
-            <a:pPr algn="l">
-              <a:lnSpc>
-                <a:spcPct val="110000"/>
-              </a:lnSpc>
-              <a:buNone/>
-              <a:defRPr sz="2800" b="0">
-                <a:solidFill>
-                  <a:srgbClr val="303437"/>
-                </a:solidFill>
-                <a:latin typeface="Noto Sans"/>
-              </a:defRPr>
-            </a:pPr>
-            <a:r>
-              <a:rPr sz="2800" b="1" lang="ja-JP" altLang="en-US">
-                <a:solidFill>
-                  <a:srgbClr val="303437"/>
-                </a:solidFill>
-                <a:latin typeface="Noto Sans"/>
-                <a:ea typeface="Noto Sans CJK JP"/>
-                <a:cs typeface="Noto Sans"/>
-              </a:rPr>
-              <a:t/>
-            </a:r>
-          </a:p>
-        </p:txBody>
-      </p:sp>
-      <p:sp>
-        <p:nvSpPr>
-          <p:cNvPr id="3" name="Text Placeholder 2"/>
-          <p:cNvSpPr>
-            <a:spLocks noGrp="1"/>
-          </p:cNvSpPr>
-          <p:nvPr>
-            <p:ph type="body" idx="1"/>
-          </p:nvPr>
-        </p:nvSpPr>
-        <p:spPr>
-          <a:xfrm>
-            <a:off x="640080" y="1663901"/>
-            <a:ext cx="7863840" cy="2362199"/>
-          </a:xfrm>
-        </p:spPr>
-        <p:txBody>
-          <a:bodyPr lIns="0" rIns="0" tIns="0" bIns="0">
-            <a:noAutofit/>
-          </a:bodyPr>
-          <a:lstStyle/>
-          <a:p>
-            <a:pPr marL="457200" indent="-457200">
-              <a:lnSpc>
-                <a:spcPts val="3660"/>
-              </a:lnSpc>
-              <a:spcAft>
-                <a:spcPts val="1200"/>
-              </a:spcAft>
-              <a:buSzPct val="100000"/>
-              <a:buFont typeface="Noto Sans CJK JP"/>
-              <a:buAutoNum type="arabicPeriod" startAt="1"/>
-              <a:defRPr sz="3000" b="1">
-                <a:solidFill>
-                  <a:srgbClr val="303437"/>
-                </a:solidFill>
-                <a:latin typeface="Noto Sans"/>
-              </a:defRPr>
-            </a:pPr>
-            <a:r>
-              <a:rPr sz="3000" b="1" lang="ja-JP" altLang="en-US">
-                <a:solidFill>
-                  <a:srgbClr val="303437"/>
-                </a:solidFill>
-                <a:latin typeface="Noto Sans"/>
-                <a:ea typeface="Noto Sans CJK JP"/>
-                <a:cs typeface="Noto Sans"/>
-              </a:rPr>
-              <a:t>医療相談と候補回答</a:t>
-            </a:r>
-          </a:p>
-          <a:p>
-            <a:pPr marL="457200" indent="-457200">
-              <a:lnSpc>
-                <a:spcPts val="3660"/>
-              </a:lnSpc>
-              <a:spcAft>
-                <a:spcPts val="1200"/>
-              </a:spcAft>
-              <a:buSzPct val="100000"/>
-              <a:buFont typeface="Noto Sans CJK JP"/>
-              <a:buAutoNum type="arabicPeriod" startAt="2"/>
-              <a:defRPr sz="3000" b="1">
-                <a:solidFill>
-                  <a:srgbClr val="303437"/>
-                </a:solidFill>
-                <a:latin typeface="Noto Sans"/>
-              </a:defRPr>
-            </a:pPr>
-            <a:r>
-              <a:rPr sz="3000" b="1" lang="ja-JP" altLang="en-US">
-                <a:solidFill>
-                  <a:srgbClr val="303437"/>
-                </a:solidFill>
-                <a:latin typeface="Noto Sans"/>
-                <a:ea typeface="Noto Sans CJK JP"/>
-                <a:cs typeface="Noto Sans"/>
-              </a:rPr>
-              <a:t>収集とデータの構成</a:t>
-            </a:r>
-          </a:p>
-          <a:p>
-            <a:pPr marL="457200" indent="-457200">
-              <a:lnSpc>
-                <a:spcPts val="3660"/>
-              </a:lnSpc>
-              <a:spcAft>
-                <a:spcPts val="1200"/>
-              </a:spcAft>
-              <a:buSzPct val="100000"/>
-              <a:buFont typeface="Noto Sans CJK JP"/>
-              <a:buAutoNum type="arabicPeriod" startAt="3"/>
-              <a:defRPr sz="3000" b="1">
-                <a:solidFill>
-                  <a:srgbClr val="303437"/>
-                </a:solidFill>
-                <a:latin typeface="Noto Sans"/>
-              </a:defRPr>
-            </a:pPr>
-            <a:r>
-              <a:rPr sz="3000" b="1" lang="ja-JP" altLang="en-US">
-                <a:solidFill>
-                  <a:srgbClr val="303437"/>
-                </a:solidFill>
-                <a:latin typeface="Noto Sans"/>
-                <a:ea typeface="Noto Sans CJK JP"/>
-                <a:cs typeface="Noto Sans"/>
-              </a:rPr>
-              <a:t>評価方法と成績</a:t>
-            </a:r>
-          </a:p>
-          <a:p>
-            <a:pPr marL="457200" indent="-457200">
-              <a:lnSpc>
-                <a:spcPts val="3660"/>
-              </a:lnSpc>
-              <a:spcAft>
-                <a:spcPts val="0"/>
-              </a:spcAft>
-              <a:buSzPct val="100000"/>
-              <a:buFont typeface="Noto Sans CJK JP"/>
-              <a:buAutoNum type="arabicPeriod" startAt="4"/>
-              <a:defRPr sz="3000" b="1">
-                <a:solidFill>
-                  <a:srgbClr val="303437"/>
-                </a:solidFill>
-                <a:latin typeface="Noto Sans"/>
-              </a:defRPr>
-            </a:pPr>
-            <a:r>
-              <a:rPr sz="3000" b="1" lang="ja-JP" altLang="en-US">
-                <a:solidFill>
-                  <a:srgbClr val="303437"/>
-                </a:solidFill>
-                <a:latin typeface="Noto Sans"/>
-                <a:ea typeface="Noto Sans CJK JP"/>
-                <a:cs typeface="Noto Sans"/>
-              </a:rPr>
-              <a:t>入手と利用</a:t>
-            </a:r>
-          </a:p>
-        </p:txBody>
-      </p:sp>
-      <p:sp>
-        <p:nvSpPr>
-          <p:cNvPr id="4" name="Title 3"/>
-          <p:cNvSpPr>
-            <a:spLocks noGrp="1"/>
-          </p:cNvSpPr>
-          <p:nvPr>
-            <p:ph type="title" idx="2"/>
-          </p:nvPr>
-        </p:nvSpPr>
-        <p:spPr>
-          <a:xfrm>
-            <a:off x="75895" y="0"/>
-            <a:ext cx="8115300" cy="480060"/>
-          </a:xfrm>
-        </p:spPr>
-        <p:txBody>
-          <a:bodyPr wrap="square" lIns="0" rIns="0" tIns="0" bIns="0" anchor="ctr">
-            <a:noAutofit/>
-          </a:bodyPr>
-          <a:lstStyle/>
-          <a:p>
-            <a:pPr algn="l">
-              <a:lnSpc>
-                <a:spcPct val="110000"/>
-              </a:lnSpc>
-              <a:buNone/>
-              <a:defRPr sz="1400" b="0">
-                <a:solidFill>
-                  <a:srgbClr val="303437"/>
-                </a:solidFill>
-                <a:latin typeface="Noto Sans"/>
-              </a:defRPr>
-            </a:pPr>
-            <a:r>
-              <a:rPr sz="1400" b="1" lang="ja-JP" altLang="en-US">
-                <a:solidFill>
-                  <a:srgbClr val="FFFEF8"/>
-                </a:solidFill>
-                <a:latin typeface="Noto Sans"/>
-                <a:ea typeface="Noto Sans CJK JP"/>
-                <a:cs typeface="Noto Sans"/>
-              </a:rPr>
-              <a:t>目次</a:t>
-            </a:r>
-          </a:p>
-        </p:txBody>
-      </p:sp>
-    </p:spTree>
-  </p:cSld>
-  <p:clrMapOvr>
-    <a:masterClrMapping/>
-  </p:clrMapOvr>
-</p:sld>
-</file>
-
-<file path=ppt/slides/slide30.xml><?xml version="1.0" encoding="utf-8"?>
+<file path=ppt/slides/slide29.xml><?xml version="1.0" encoding="utf-8"?>
 <p:sld xmlns:a="http://schemas.openxmlformats.org/drawingml/2006/main" xmlns:p="http://schemas.openxmlformats.org/presentationml/2006/main" xmlns:r="http://schemas.openxmlformats.org/officeDocument/2006/relationships">
   <p:cSld>
     <p:spTree>
@@ -16796,7 +16179,264 @@
 </p:sld>
 </file>
 
-<file path=ppt/slides/slide31.xml><?xml version="1.0" encoding="utf-8"?>
+<file path=ppt/slides/slide3.xml><?xml version="1.0" encoding="utf-8"?>
+<p:sld xmlns:a="http://schemas.openxmlformats.org/drawingml/2006/main" xmlns:p="http://schemas.openxmlformats.org/presentationml/2006/main" xmlns:r="http://schemas.openxmlformats.org/officeDocument/2006/relationships">
+  <p:cSld>
+    <p:spTree>
+      <p:nvGrpSpPr>
+        <p:cNvPr id="1" name=""/>
+        <p:cNvGrpSpPr/>
+        <p:nvPr/>
+      </p:nvGrpSpPr>
+      <p:grpSpPr/>
+      <p:sp>
+        <p:nvSpPr>
+          <p:cNvPr id="2" name="Title 1"/>
+          <p:cNvSpPr>
+            <a:spLocks noGrp="1"/>
+          </p:cNvSpPr>
+          <p:nvPr>
+            <p:ph type="title"/>
+          </p:nvPr>
+        </p:nvSpPr>
+        <p:spPr>
+          <a:xfrm>
+            <a:off x="468172" y="650138"/>
+            <a:ext cx="8206740" cy="616305"/>
+          </a:xfrm>
+        </p:spPr>
+        <p:txBody>
+          <a:bodyPr wrap="square" lIns="0" rIns="0" tIns="0" bIns="0">
+            <a:noAutofit/>
+          </a:bodyPr>
+          <a:lstStyle/>
+          <a:p>
+            <a:pPr algn="l">
+              <a:lnSpc>
+                <a:spcPct val="110000"/>
+              </a:lnSpc>
+              <a:buNone/>
+              <a:defRPr sz="2800" b="0">
+                <a:solidFill>
+                  <a:srgbClr val="303437"/>
+                </a:solidFill>
+                <a:latin typeface="Noto Sans"/>
+              </a:defRPr>
+            </a:pPr>
+            <a:r>
+              <a:rPr sz="2800" b="1" lang="ja-JP" altLang="en-US">
+                <a:solidFill>
+                  <a:srgbClr val="303437"/>
+                </a:solidFill>
+                <a:latin typeface="Noto Sans"/>
+                <a:ea typeface="Noto Sans CJK JP"/>
+                <a:cs typeface="Noto Sans"/>
+              </a:rPr>
+              <a:t/>
+            </a:r>
+          </a:p>
+        </p:txBody>
+      </p:sp>
+      <p:sp>
+        <p:nvSpPr>
+          <p:cNvPr id="3" name="Text Placeholder 2"/>
+          <p:cNvSpPr>
+            <a:spLocks noGrp="1"/>
+          </p:cNvSpPr>
+          <p:nvPr>
+            <p:ph type="body" idx="1"/>
+          </p:nvPr>
+        </p:nvSpPr>
+        <p:spPr>
+          <a:xfrm>
+            <a:off x="640080" y="1663901"/>
+            <a:ext cx="7863840" cy="2362199"/>
+          </a:xfrm>
+        </p:spPr>
+        <p:txBody>
+          <a:bodyPr lIns="0" rIns="0" tIns="0" bIns="0">
+            <a:noAutofit/>
+          </a:bodyPr>
+          <a:lstStyle/>
+          <a:p>
+            <a:pPr marL="457200" indent="-457200">
+              <a:lnSpc>
+                <a:spcPts val="3660"/>
+              </a:lnSpc>
+              <a:spcAft>
+                <a:spcPts val="1200"/>
+              </a:spcAft>
+              <a:buSzPct val="100000"/>
+              <a:buFont typeface="Noto Sans CJK JP"/>
+              <a:buAutoNum type="arabicPeriod" startAt="1"/>
+              <a:defRPr sz="3000" b="1">
+                <a:solidFill>
+                  <a:srgbClr val="303437"/>
+                </a:solidFill>
+                <a:latin typeface="Noto Sans"/>
+              </a:defRPr>
+            </a:pPr>
+            <a:r>
+              <a:rPr sz="3000" b="1" lang="ja-JP" altLang="en-US">
+                <a:solidFill>
+                  <a:srgbClr val="303437"/>
+                </a:solidFill>
+                <a:latin typeface="Noto Sans"/>
+                <a:ea typeface="Noto Sans CJK JP"/>
+                <a:cs typeface="Noto Sans"/>
+              </a:rPr>
+              <a:t>医療相談と候補回答</a:t>
+            </a:r>
+          </a:p>
+          <a:p>
+            <a:pPr marL="457200" indent="-457200">
+              <a:lnSpc>
+                <a:spcPts val="3660"/>
+              </a:lnSpc>
+              <a:spcAft>
+                <a:spcPts val="1200"/>
+              </a:spcAft>
+              <a:buSzPct val="100000"/>
+              <a:buFont typeface="Noto Sans CJK JP"/>
+              <a:buAutoNum type="arabicPeriod" startAt="2"/>
+              <a:defRPr sz="3000" b="1">
+                <a:solidFill>
+                  <a:srgbClr val="303437"/>
+                </a:solidFill>
+                <a:latin typeface="Noto Sans"/>
+              </a:defRPr>
+            </a:pPr>
+            <a:r>
+              <a:rPr sz="3000" b="1" lang="ja-JP" altLang="en-US">
+                <a:solidFill>
+                  <a:srgbClr val="303437"/>
+                </a:solidFill>
+                <a:latin typeface="Noto Sans"/>
+                <a:ea typeface="Noto Sans CJK JP"/>
+                <a:cs typeface="Noto Sans"/>
+              </a:rPr>
+              <a:t>収集とデータの構成</a:t>
+            </a:r>
+          </a:p>
+          <a:p>
+            <a:pPr marL="457200" indent="-457200">
+              <a:lnSpc>
+                <a:spcPts val="3660"/>
+              </a:lnSpc>
+              <a:spcAft>
+                <a:spcPts val="1200"/>
+              </a:spcAft>
+              <a:buSzPct val="100000"/>
+              <a:buFont typeface="Noto Sans CJK JP"/>
+              <a:buAutoNum type="arabicPeriod" startAt="3"/>
+              <a:defRPr sz="3000" b="1">
+                <a:solidFill>
+                  <a:srgbClr val="303437"/>
+                </a:solidFill>
+                <a:latin typeface="Noto Sans"/>
+              </a:defRPr>
+            </a:pPr>
+            <a:r>
+              <a:rPr sz="3000" b="1" lang="ja-JP" altLang="en-US">
+                <a:solidFill>
+                  <a:srgbClr val="303437"/>
+                </a:solidFill>
+                <a:latin typeface="Noto Sans"/>
+                <a:ea typeface="Noto Sans CJK JP"/>
+                <a:cs typeface="Noto Sans"/>
+              </a:rPr>
+              <a:t>評価方法と成績</a:t>
+            </a:r>
+          </a:p>
+          <a:p>
+            <a:pPr marL="457200" indent="-457200">
+              <a:lnSpc>
+                <a:spcPts val="3660"/>
+              </a:lnSpc>
+              <a:spcAft>
+                <a:spcPts val="0"/>
+              </a:spcAft>
+              <a:buSzPct val="100000"/>
+              <a:buFont typeface="Noto Sans CJK JP"/>
+              <a:buAutoNum type="arabicPeriod" startAt="4"/>
+              <a:defRPr sz="3000" b="1">
+                <a:solidFill>
+                  <a:srgbClr val="303437"/>
+                </a:solidFill>
+                <a:latin typeface="Noto Sans"/>
+              </a:defRPr>
+            </a:pPr>
+            <a:r>
+              <a:rPr sz="3000" b="1" lang="ja-JP" altLang="en-US">
+                <a:solidFill>
+                  <a:srgbClr val="303437"/>
+                </a:solidFill>
+                <a:latin typeface="Noto Sans"/>
+                <a:ea typeface="Noto Sans CJK JP"/>
+                <a:cs typeface="Noto Sans"/>
+              </a:rPr>
+              <a:t>入手と利用</a:t>
+            </a:r>
+          </a:p>
+        </p:txBody>
+      </p:sp>
+      <p:sp>
+        <p:nvSpPr>
+          <p:cNvPr id="4" name="Title 3"/>
+          <p:cNvSpPr>
+            <a:spLocks noGrp="1"/>
+          </p:cNvSpPr>
+          <p:nvPr>
+            <p:ph type="title" idx="2"/>
+          </p:nvPr>
+        </p:nvSpPr>
+        <p:spPr>
+          <a:xfrm>
+            <a:off x="75895" y="0"/>
+            <a:ext cx="8115300" cy="480060"/>
+          </a:xfrm>
+        </p:spPr>
+        <p:txBody>
+          <a:bodyPr wrap="square" lIns="0" rIns="0" tIns="0" bIns="0" anchor="ctr">
+            <a:noAutofit/>
+          </a:bodyPr>
+          <a:lstStyle/>
+          <a:p>
+            <a:pPr algn="l">
+              <a:lnSpc>
+                <a:spcPct val="110000"/>
+              </a:lnSpc>
+              <a:buNone/>
+              <a:defRPr sz="1400" b="0">
+                <a:solidFill>
+                  <a:srgbClr val="303437"/>
+                </a:solidFill>
+                <a:latin typeface="Noto Sans"/>
+              </a:defRPr>
+            </a:pPr>
+            <a:r>
+              <a:rPr sz="1400" b="1" lang="ja-JP" altLang="en-US">
+                <a:solidFill>
+                  <a:srgbClr val="FFFEF8"/>
+                </a:solidFill>
+                <a:latin typeface="Noto Sans"/>
+                <a:ea typeface="Noto Sans CJK JP"/>
+                <a:cs typeface="Noto Sans"/>
+              </a:rPr>
+              <a:t>目次</a:t>
+            </a:r>
+          </a:p>
+        </p:txBody>
+      </p:sp>
+    </p:spTree>
+  </p:cSld>
+  <p:clrMapOvr>
+    <a:masterClrMapping/>
+  </p:clrMapOvr>
+</p:sld>
+</file>
+
+<file path=ppt/slides/slide30.xml><?xml version="1.0" encoding="utf-8"?>
 <p:sld xmlns:a="http://schemas.openxmlformats.org/drawingml/2006/main" xmlns:p="http://schemas.openxmlformats.org/presentationml/2006/main" xmlns:r="http://schemas.openxmlformats.org/officeDocument/2006/relationships">
   <p:cSld>
     <p:spTree>
@@ -17359,7 +16999,7 @@
 </p:sld>
 </file>
 
-<file path=ppt/slides/slide32.xml><?xml version="1.0" encoding="utf-8"?>
+<file path=ppt/slides/slide31.xml><?xml version="1.0" encoding="utf-8"?>
 <p:sld xmlns:a="http://schemas.openxmlformats.org/drawingml/2006/main" xmlns:p="http://schemas.openxmlformats.org/presentationml/2006/main" xmlns:r="http://schemas.openxmlformats.org/officeDocument/2006/relationships">
   <p:cSld>
     <p:spTree>
@@ -17922,7 +17562,7 @@
 </p:sld>
 </file>
 
-<file path=ppt/slides/slide33.xml><?xml version="1.0" encoding="utf-8"?>
+<file path=ppt/slides/slide32.xml><?xml version="1.0" encoding="utf-8"?>
 <p:sld xmlns:a="http://schemas.openxmlformats.org/drawingml/2006/main" xmlns:p="http://schemas.openxmlformats.org/presentationml/2006/main" xmlns:r="http://schemas.openxmlformats.org/officeDocument/2006/relationships">
   <p:cSld>
     <p:spTree>
@@ -18485,7 +18125,7 @@
 </p:sld>
 </file>
 
-<file path=ppt/slides/slide34.xml><?xml version="1.0" encoding="utf-8"?>
+<file path=ppt/slides/slide33.xml><?xml version="1.0" encoding="utf-8"?>
 <p:sld xmlns:a="http://schemas.openxmlformats.org/drawingml/2006/main" xmlns:p="http://schemas.openxmlformats.org/presentationml/2006/main" xmlns:r="http://schemas.openxmlformats.org/officeDocument/2006/relationships">
   <p:cSld>
     <p:spTree>
@@ -19048,7 +18688,7 @@
 </p:sld>
 </file>
 
-<file path=ppt/slides/slide35.xml><?xml version="1.0" encoding="utf-8"?>
+<file path=ppt/slides/slide34.xml><?xml version="1.0" encoding="utf-8"?>
 <p:sld xmlns:a="http://schemas.openxmlformats.org/drawingml/2006/main" xmlns:p="http://schemas.openxmlformats.org/presentationml/2006/main" xmlns:r="http://schemas.openxmlformats.org/officeDocument/2006/relationships">
   <p:cSld>
     <p:spTree>
@@ -19611,7 +19251,7 @@
 </p:sld>
 </file>
 
-<file path=ppt/slides/slide36.xml><?xml version="1.0" encoding="utf-8"?>
+<file path=ppt/slides/slide35.xml><?xml version="1.0" encoding="utf-8"?>
 <p:sld xmlns:a="http://schemas.openxmlformats.org/drawingml/2006/main" xmlns:p="http://schemas.openxmlformats.org/presentationml/2006/main" xmlns:r="http://schemas.openxmlformats.org/officeDocument/2006/relationships">
   <p:cSld>
     <p:spTree>
@@ -20174,7 +19814,7 @@
 </p:sld>
 </file>
 
-<file path=ppt/slides/slide37.xml><?xml version="1.0" encoding="utf-8"?>
+<file path=ppt/slides/slide36.xml><?xml version="1.0" encoding="utf-8"?>
 <p:sld xmlns:a="http://schemas.openxmlformats.org/drawingml/2006/main" xmlns:p="http://schemas.openxmlformats.org/presentationml/2006/main" xmlns:r="http://schemas.openxmlformats.org/officeDocument/2006/relationships">
   <p:cSld>
     <p:spTree>
@@ -20288,7 +19928,7 @@
 </p:sld>
 </file>
 
-<file path=ppt/slides/slide38.xml><?xml version="1.0" encoding="utf-8"?>
+<file path=ppt/slides/slide37.xml><?xml version="1.0" encoding="utf-8"?>
 <p:sld xmlns:a="http://schemas.openxmlformats.org/drawingml/2006/main" xmlns:p="http://schemas.openxmlformats.org/presentationml/2006/main" xmlns:r="http://schemas.openxmlformats.org/officeDocument/2006/relationships">
   <p:cSld>
     <p:spTree>
@@ -21050,7 +20690,7 @@
 </p:sld>
 </file>
 
-<file path=ppt/slides/slide39.xml><?xml version="1.0" encoding="utf-8"?>
+<file path=ppt/slides/slide38.xml><?xml version="1.0" encoding="utf-8"?>
 <p:sld xmlns:a="http://schemas.openxmlformats.org/drawingml/2006/main" xmlns:p="http://schemas.openxmlformats.org/presentationml/2006/main" xmlns:r="http://schemas.openxmlformats.org/officeDocument/2006/relationships">
   <p:cSld>
     <p:spTree>
@@ -21964,6 +21604,310 @@
 </p:sld>
 </file>
 
+<file path=ppt/slides/slide39.xml><?xml version="1.0" encoding="utf-8"?>
+<p:sld xmlns:a="http://schemas.openxmlformats.org/drawingml/2006/main" xmlns:p="http://schemas.openxmlformats.org/presentationml/2006/main" xmlns:r="http://schemas.openxmlformats.org/officeDocument/2006/relationships">
+  <p:cSld>
+    <p:spTree>
+      <p:nvGrpSpPr>
+        <p:cNvPr id="1" name=""/>
+        <p:cNvGrpSpPr/>
+        <p:nvPr/>
+      </p:nvGrpSpPr>
+      <p:grpSpPr/>
+      <p:sp>
+        <p:nvSpPr>
+          <p:cNvPr id="2" name="Title 1"/>
+          <p:cNvSpPr>
+            <a:spLocks noGrp="1"/>
+          </p:cNvSpPr>
+          <p:nvPr>
+            <p:ph type="title"/>
+          </p:nvPr>
+        </p:nvSpPr>
+        <p:spPr>
+          <a:xfrm>
+            <a:off x="468172" y="650138"/>
+            <a:ext cx="8206740" cy="616305"/>
+          </a:xfrm>
+        </p:spPr>
+        <p:txBody>
+          <a:bodyPr wrap="square" lIns="0" rIns="0" tIns="0" bIns="0">
+            <a:noAutofit/>
+          </a:bodyPr>
+          <a:lstStyle/>
+          <a:p>
+            <a:pPr algn="l">
+              <a:lnSpc>
+                <a:spcPct val="110000"/>
+              </a:lnSpc>
+              <a:buNone/>
+              <a:defRPr sz="2800" b="0">
+                <a:solidFill>
+                  <a:srgbClr val="303437"/>
+                </a:solidFill>
+                <a:latin typeface="Noto Sans"/>
+              </a:defRPr>
+            </a:pPr>
+            <a:r>
+              <a:rPr sz="2800" b="1" lang="ja-JP" altLang="en-US">
+                <a:solidFill>
+                  <a:srgbClr val="303437"/>
+                </a:solidFill>
+                <a:latin typeface="Noto Sans"/>
+                <a:ea typeface="Noto Sans CJK JP"/>
+                <a:cs typeface="Noto Sans"/>
+              </a:rPr>
+              <a:t>候補ファイルは、対応回答を先頭に並べている</a:t>
+            </a:r>
+          </a:p>
+        </p:txBody>
+      </p:sp>
+      <p:sp>
+        <p:nvSpPr>
+          <p:cNvPr id="3" name="Text Placeholder 2"/>
+          <p:cNvSpPr>
+            <a:spLocks noGrp="1"/>
+          </p:cNvSpPr>
+          <p:nvPr>
+            <p:ph type="body" idx="1"/>
+          </p:nvPr>
+        </p:nvSpPr>
+        <p:spPr>
+          <a:xfrm>
+            <a:off x="594360" y="1463040"/>
+            <a:ext cx="7955279" cy="3044952"/>
+          </a:xfrm>
+        </p:spPr>
+        <p:txBody>
+          <a:bodyPr wrap="square" tIns="91440" bIns="91440">
+            <a:noAutofit/>
+          </a:bodyPr>
+          <a:lstStyle/>
+          <a:p>
+            <a:pPr marL="457200" indent="-355600">
+              <a:lnSpc>
+                <a:spcPts val="2499"/>
+              </a:lnSpc>
+              <a:spcAft>
+                <a:spcPts val="700"/>
+              </a:spcAft>
+              <a:buSzPct val="63333"/>
+              <a:buFont typeface="Noto Sans CJK JP"/>
+              <a:buChar char="●"/>
+              <a:defRPr sz="2100" b="0">
+                <a:solidFill>
+                  <a:srgbClr val="303437"/>
+                </a:solidFill>
+                <a:latin typeface="Noto Sans"/>
+              </a:defRPr>
+            </a:pPr>
+            <a:r>
+              <a:rPr sz="2100" b="0" lang="ja-JP" altLang="en-US">
+                <a:solidFill>
+                  <a:srgbClr val="303437"/>
+                </a:solidFill>
+                <a:latin typeface="Noto Sans"/>
+                <a:ea typeface="Noto Sans CJK JP"/>
+                <a:cs typeface="Noto Sans"/>
+              </a:rPr>
+              <a:t>dev/testの候補ファイルでは、各質問に対応する回答が先頭に並び、その後に別の質問への回答が続く。cnt欄は、この保存順を表している。</a:t>
+            </a:r>
+          </a:p>
+          <a:p>
+            <a:pPr marL="457200" indent="-355600">
+              <a:lnSpc>
+                <a:spcPts val="2499"/>
+              </a:lnSpc>
+              <a:spcAft>
+                <a:spcPts val="700"/>
+              </a:spcAft>
+              <a:buSzPct val="63333"/>
+              <a:buFont typeface="Noto Sans CJK JP"/>
+              <a:buChar char="●"/>
+              <a:defRPr sz="2100" b="0">
+                <a:solidFill>
+                  <a:srgbClr val="303437"/>
+                </a:solidFill>
+                <a:latin typeface="Noto Sans"/>
+              </a:defRPr>
+            </a:pPr>
+            <a:r>
+              <a:rPr sz="2100" b="0" lang="ja-JP" altLang="en-US">
+                <a:solidFill>
+                  <a:srgbClr val="303437"/>
+                </a:solidFill>
+                <a:latin typeface="Noto Sans"/>
+                <a:ea typeface="Noto Sans CJK JP"/>
+                <a:cs typeface="Noto Sans"/>
+              </a:rPr>
+              <a:t>評価時には、質問と回答の内容からモデルが計算したスコアで候補を並べ替える。</a:t>
+            </a:r>
+          </a:p>
+          <a:p>
+            <a:pPr marL="457200" indent="-355600">
+              <a:lnSpc>
+                <a:spcPts val="2499"/>
+              </a:lnSpc>
+              <a:spcAft>
+                <a:spcPts val="0"/>
+              </a:spcAft>
+              <a:buSzPct val="63333"/>
+              <a:buFont typeface="Noto Sans CJK JP"/>
+              <a:buChar char="●"/>
+              <a:defRPr sz="2100" b="0">
+                <a:solidFill>
+                  <a:srgbClr val="303437"/>
+                </a:solidFill>
+                <a:latin typeface="Noto Sans"/>
+              </a:defRPr>
+            </a:pPr>
+            <a:r>
+              <a:rPr sz="2100" b="0" lang="ja-JP" altLang="en-US">
+                <a:solidFill>
+                  <a:srgbClr val="303437"/>
+                </a:solidFill>
+                <a:latin typeface="Noto Sans"/>
+                <a:ea typeface="Noto Sans CJK JP"/>
+                <a:cs typeface="Noto Sans"/>
+              </a:rPr>
+              <a:t>一つの質問の候補に、同じ回答IDが繰り返し含まれることもある。</a:t>
+            </a:r>
+          </a:p>
+        </p:txBody>
+      </p:sp>
+      <p:sp>
+        <p:nvSpPr>
+          <p:cNvPr id="4" name="Title 3"/>
+          <p:cNvSpPr>
+            <a:spLocks noGrp="1"/>
+          </p:cNvSpPr>
+          <p:nvPr>
+            <p:ph type="title" idx="2"/>
+          </p:nvPr>
+        </p:nvSpPr>
+        <p:spPr>
+          <a:xfrm>
+            <a:off x="75895" y="0"/>
+            <a:ext cx="8115300" cy="480060"/>
+          </a:xfrm>
+        </p:spPr>
+        <p:txBody>
+          <a:bodyPr wrap="square" lIns="0" rIns="0" tIns="0" bIns="0" anchor="ctr">
+            <a:noAutofit/>
+          </a:bodyPr>
+          <a:lstStyle/>
+          <a:p>
+            <a:pPr algn="l">
+              <a:lnSpc>
+                <a:spcPct val="110000"/>
+              </a:lnSpc>
+              <a:buNone/>
+              <a:defRPr sz="1400" b="0">
+                <a:solidFill>
+                  <a:srgbClr val="303437"/>
+                </a:solidFill>
+                <a:latin typeface="Noto Sans"/>
+              </a:defRPr>
+            </a:pPr>
+            <a:r>
+              <a:rPr sz="1400" b="1" lang="ja-JP" altLang="en-US">
+                <a:solidFill>
+                  <a:srgbClr val="FFFEF8"/>
+                </a:solidFill>
+                <a:latin typeface="Noto Sans"/>
+                <a:ea typeface="Noto Sans CJK JP"/>
+                <a:cs typeface="Noto Sans"/>
+              </a:rPr>
+              <a:t>Appendix: 2. データ利用の補足</a:t>
+            </a:r>
+          </a:p>
+        </p:txBody>
+      </p:sp>
+      <p:sp>
+        <p:nvSpPr>
+          <p:cNvPr id="5" name="sources"/>
+          <p:cNvSpPr txBox="1"/>
+          <p:nvPr/>
+        </p:nvSpPr>
+        <p:spPr>
+          <a:xfrm>
+            <a:off x="502920" y="4754880"/>
+            <a:ext cx="8183879" cy="530352"/>
+          </a:xfrm>
+          <a:prstGeom prst="rect">
+            <a:avLst/>
+          </a:prstGeom>
+          <a:noFill/>
+        </p:spPr>
+        <p:txBody>
+          <a:bodyPr wrap="square" lIns="0" rIns="0" tIns="0" bIns="0">
+            <a:noAutofit/>
+          </a:bodyPr>
+          <a:lstStyle/>
+          <a:p>
+            <a:pPr algn="l">
+              <a:lnSpc>
+                <a:spcPts val="940"/>
+              </a:lnSpc>
+              <a:spcBef>
+                <a:spcPts val="0"/>
+              </a:spcBef>
+              <a:spcAft>
+                <a:spcPts val="140"/>
+              </a:spcAft>
+              <a:buNone/>
+              <a:defRPr sz="810" b="0">
+                <a:solidFill>
+                  <a:srgbClr val="303437"/>
+                </a:solidFill>
+                <a:latin typeface="Noto Sans"/>
+              </a:defRPr>
+            </a:pPr>
+            <a:r>
+              <a:rPr sz="810" b="0" lang="ja-JP" altLang="en-US">
+                <a:solidFill>
+                  <a:srgbClr val="626669"/>
+                </a:solidFill>
+                <a:latin typeface="Noto Sans"/>
+                <a:ea typeface="Noto Sans CJK JP"/>
+                <a:cs typeface="Noto Sans"/>
+              </a:rPr>
+              <a:t>[1] Zhang et al. (n.d.). cMedQA2. GitHub (accessed 2026-10-18).</a:t>
+            </a:r>
+            <a:r>
+              <a:rPr sz="810" b="0" lang="ja-JP" altLang="en-US">
+                <a:solidFill>
+                  <a:srgbClr val="626669"/>
+                </a:solidFill>
+                <a:latin typeface="Noto Sans"/>
+                <a:ea typeface="Noto Sans CJK JP"/>
+                <a:cs typeface="Noto Sans"/>
+              </a:rPr>
+              <a:t>  </a:t>
+            </a:r>
+            <a:r>
+              <a:rPr sz="810" b="0" lang="ja-JP" altLang="en-US">
+                <a:solidFill>
+                  <a:srgbClr val="626669"/>
+                </a:solidFill>
+                <a:latin typeface="Noto Sans"/>
+                <a:ea typeface="Noto Sans CJK JP"/>
+                <a:cs typeface="Noto Sans"/>
+                <a:hlinkClick r:id="rId2"/>
+              </a:rPr>
+              <a:t>https://github.com/zhangsheng93/cMedQA2</a:t>
+            </a:r>
+          </a:p>
+        </p:txBody>
+      </p:sp>
+    </p:spTree>
+  </p:cSld>
+  <p:clrMapOvr>
+    <a:masterClrMapping/>
+  </p:clrMapOvr>
+</p:sld>
+</file>
+
 <file path=ppt/slides/slide4.xml><?xml version="1.0" encoding="utf-8"?>
 <p:sld xmlns:a="http://schemas.openxmlformats.org/drawingml/2006/main" xmlns:p="http://schemas.openxmlformats.org/presentationml/2006/main" xmlns:r="http://schemas.openxmlformats.org/officeDocument/2006/relationships">
   <p:cSld>
@@ -22079,310 +22023,6 @@
 </file>
 
 <file path=ppt/slides/slide40.xml><?xml version="1.0" encoding="utf-8"?>
-<p:sld xmlns:a="http://schemas.openxmlformats.org/drawingml/2006/main" xmlns:p="http://schemas.openxmlformats.org/presentationml/2006/main" xmlns:r="http://schemas.openxmlformats.org/officeDocument/2006/relationships">
-  <p:cSld>
-    <p:spTree>
-      <p:nvGrpSpPr>
-        <p:cNvPr id="1" name=""/>
-        <p:cNvGrpSpPr/>
-        <p:nvPr/>
-      </p:nvGrpSpPr>
-      <p:grpSpPr/>
-      <p:sp>
-        <p:nvSpPr>
-          <p:cNvPr id="2" name="Title 1"/>
-          <p:cNvSpPr>
-            <a:spLocks noGrp="1"/>
-          </p:cNvSpPr>
-          <p:nvPr>
-            <p:ph type="title"/>
-          </p:nvPr>
-        </p:nvSpPr>
-        <p:spPr>
-          <a:xfrm>
-            <a:off x="468172" y="650138"/>
-            <a:ext cx="8206740" cy="616305"/>
-          </a:xfrm>
-        </p:spPr>
-        <p:txBody>
-          <a:bodyPr wrap="square" lIns="0" rIns="0" tIns="0" bIns="0">
-            <a:noAutofit/>
-          </a:bodyPr>
-          <a:lstStyle/>
-          <a:p>
-            <a:pPr algn="l">
-              <a:lnSpc>
-                <a:spcPct val="110000"/>
-              </a:lnSpc>
-              <a:buNone/>
-              <a:defRPr sz="2800" b="0">
-                <a:solidFill>
-                  <a:srgbClr val="303437"/>
-                </a:solidFill>
-                <a:latin typeface="Noto Sans"/>
-              </a:defRPr>
-            </a:pPr>
-            <a:r>
-              <a:rPr sz="2800" b="1" lang="ja-JP" altLang="en-US">
-                <a:solidFill>
-                  <a:srgbClr val="303437"/>
-                </a:solidFill>
-                <a:latin typeface="Noto Sans"/>
-                <a:ea typeface="Noto Sans CJK JP"/>
-                <a:cs typeface="Noto Sans"/>
-              </a:rPr>
-              <a:t>候補ファイルは、対応回答を先頭に並べている</a:t>
-            </a:r>
-          </a:p>
-        </p:txBody>
-      </p:sp>
-      <p:sp>
-        <p:nvSpPr>
-          <p:cNvPr id="3" name="Text Placeholder 2"/>
-          <p:cNvSpPr>
-            <a:spLocks noGrp="1"/>
-          </p:cNvSpPr>
-          <p:nvPr>
-            <p:ph type="body" idx="1"/>
-          </p:nvPr>
-        </p:nvSpPr>
-        <p:spPr>
-          <a:xfrm>
-            <a:off x="594360" y="1463040"/>
-            <a:ext cx="7955279" cy="3044952"/>
-          </a:xfrm>
-        </p:spPr>
-        <p:txBody>
-          <a:bodyPr wrap="square" tIns="91440" bIns="91440">
-            <a:noAutofit/>
-          </a:bodyPr>
-          <a:lstStyle/>
-          <a:p>
-            <a:pPr marL="457200" indent="-355600">
-              <a:lnSpc>
-                <a:spcPts val="2499"/>
-              </a:lnSpc>
-              <a:spcAft>
-                <a:spcPts val="700"/>
-              </a:spcAft>
-              <a:buSzPct val="63333"/>
-              <a:buFont typeface="Noto Sans CJK JP"/>
-              <a:buChar char="●"/>
-              <a:defRPr sz="2100" b="0">
-                <a:solidFill>
-                  <a:srgbClr val="303437"/>
-                </a:solidFill>
-                <a:latin typeface="Noto Sans"/>
-              </a:defRPr>
-            </a:pPr>
-            <a:r>
-              <a:rPr sz="2100" b="0" lang="ja-JP" altLang="en-US">
-                <a:solidFill>
-                  <a:srgbClr val="303437"/>
-                </a:solidFill>
-                <a:latin typeface="Noto Sans"/>
-                <a:ea typeface="Noto Sans CJK JP"/>
-                <a:cs typeface="Noto Sans"/>
-              </a:rPr>
-              <a:t>dev/testの候補ファイルでは、各質問に対応する回答が先頭に並び、その後に別の質問への回答が続く。cnt欄は、この保存順を表している。</a:t>
-            </a:r>
-          </a:p>
-          <a:p>
-            <a:pPr marL="457200" indent="-355600">
-              <a:lnSpc>
-                <a:spcPts val="2499"/>
-              </a:lnSpc>
-              <a:spcAft>
-                <a:spcPts val="700"/>
-              </a:spcAft>
-              <a:buSzPct val="63333"/>
-              <a:buFont typeface="Noto Sans CJK JP"/>
-              <a:buChar char="●"/>
-              <a:defRPr sz="2100" b="0">
-                <a:solidFill>
-                  <a:srgbClr val="303437"/>
-                </a:solidFill>
-                <a:latin typeface="Noto Sans"/>
-              </a:defRPr>
-            </a:pPr>
-            <a:r>
-              <a:rPr sz="2100" b="0" lang="ja-JP" altLang="en-US">
-                <a:solidFill>
-                  <a:srgbClr val="303437"/>
-                </a:solidFill>
-                <a:latin typeface="Noto Sans"/>
-                <a:ea typeface="Noto Sans CJK JP"/>
-                <a:cs typeface="Noto Sans"/>
-              </a:rPr>
-              <a:t>評価時には、質問と回答の内容からモデルが計算したスコアで候補を並べ替える。</a:t>
-            </a:r>
-          </a:p>
-          <a:p>
-            <a:pPr marL="457200" indent="-355600">
-              <a:lnSpc>
-                <a:spcPts val="2499"/>
-              </a:lnSpc>
-              <a:spcAft>
-                <a:spcPts val="0"/>
-              </a:spcAft>
-              <a:buSzPct val="63333"/>
-              <a:buFont typeface="Noto Sans CJK JP"/>
-              <a:buChar char="●"/>
-              <a:defRPr sz="2100" b="0">
-                <a:solidFill>
-                  <a:srgbClr val="303437"/>
-                </a:solidFill>
-                <a:latin typeface="Noto Sans"/>
-              </a:defRPr>
-            </a:pPr>
-            <a:r>
-              <a:rPr sz="2100" b="0" lang="ja-JP" altLang="en-US">
-                <a:solidFill>
-                  <a:srgbClr val="303437"/>
-                </a:solidFill>
-                <a:latin typeface="Noto Sans"/>
-                <a:ea typeface="Noto Sans CJK JP"/>
-                <a:cs typeface="Noto Sans"/>
-              </a:rPr>
-              <a:t>一つの質問の候補に、同じ回答IDが繰り返し含まれることもある。</a:t>
-            </a:r>
-          </a:p>
-        </p:txBody>
-      </p:sp>
-      <p:sp>
-        <p:nvSpPr>
-          <p:cNvPr id="4" name="Title 3"/>
-          <p:cNvSpPr>
-            <a:spLocks noGrp="1"/>
-          </p:cNvSpPr>
-          <p:nvPr>
-            <p:ph type="title" idx="2"/>
-          </p:nvPr>
-        </p:nvSpPr>
-        <p:spPr>
-          <a:xfrm>
-            <a:off x="75895" y="0"/>
-            <a:ext cx="8115300" cy="480060"/>
-          </a:xfrm>
-        </p:spPr>
-        <p:txBody>
-          <a:bodyPr wrap="square" lIns="0" rIns="0" tIns="0" bIns="0" anchor="ctr">
-            <a:noAutofit/>
-          </a:bodyPr>
-          <a:lstStyle/>
-          <a:p>
-            <a:pPr algn="l">
-              <a:lnSpc>
-                <a:spcPct val="110000"/>
-              </a:lnSpc>
-              <a:buNone/>
-              <a:defRPr sz="1400" b="0">
-                <a:solidFill>
-                  <a:srgbClr val="303437"/>
-                </a:solidFill>
-                <a:latin typeface="Noto Sans"/>
-              </a:defRPr>
-            </a:pPr>
-            <a:r>
-              <a:rPr sz="1400" b="1" lang="ja-JP" altLang="en-US">
-                <a:solidFill>
-                  <a:srgbClr val="FFFEF8"/>
-                </a:solidFill>
-                <a:latin typeface="Noto Sans"/>
-                <a:ea typeface="Noto Sans CJK JP"/>
-                <a:cs typeface="Noto Sans"/>
-              </a:rPr>
-              <a:t>Appendix: 2. データ利用の補足</a:t>
-            </a:r>
-          </a:p>
-        </p:txBody>
-      </p:sp>
-      <p:sp>
-        <p:nvSpPr>
-          <p:cNvPr id="5" name="sources"/>
-          <p:cNvSpPr txBox="1"/>
-          <p:nvPr/>
-        </p:nvSpPr>
-        <p:spPr>
-          <a:xfrm>
-            <a:off x="502920" y="4754880"/>
-            <a:ext cx="8183879" cy="530352"/>
-          </a:xfrm>
-          <a:prstGeom prst="rect">
-            <a:avLst/>
-          </a:prstGeom>
-          <a:noFill/>
-        </p:spPr>
-        <p:txBody>
-          <a:bodyPr wrap="square" lIns="0" rIns="0" tIns="0" bIns="0">
-            <a:noAutofit/>
-          </a:bodyPr>
-          <a:lstStyle/>
-          <a:p>
-            <a:pPr algn="l">
-              <a:lnSpc>
-                <a:spcPts val="940"/>
-              </a:lnSpc>
-              <a:spcBef>
-                <a:spcPts val="0"/>
-              </a:spcBef>
-              <a:spcAft>
-                <a:spcPts val="140"/>
-              </a:spcAft>
-              <a:buNone/>
-              <a:defRPr sz="810" b="0">
-                <a:solidFill>
-                  <a:srgbClr val="303437"/>
-                </a:solidFill>
-                <a:latin typeface="Noto Sans"/>
-              </a:defRPr>
-            </a:pPr>
-            <a:r>
-              <a:rPr sz="810" b="0" lang="ja-JP" altLang="en-US">
-                <a:solidFill>
-                  <a:srgbClr val="626669"/>
-                </a:solidFill>
-                <a:latin typeface="Noto Sans"/>
-                <a:ea typeface="Noto Sans CJK JP"/>
-                <a:cs typeface="Noto Sans"/>
-              </a:rPr>
-              <a:t>[1] Zhang et al. (n.d.). cMedQA2. GitHub (accessed 2026-10-18).</a:t>
-            </a:r>
-            <a:r>
-              <a:rPr sz="810" b="0" lang="ja-JP" altLang="en-US">
-                <a:solidFill>
-                  <a:srgbClr val="626669"/>
-                </a:solidFill>
-                <a:latin typeface="Noto Sans"/>
-                <a:ea typeface="Noto Sans CJK JP"/>
-                <a:cs typeface="Noto Sans"/>
-              </a:rPr>
-              <a:t>  </a:t>
-            </a:r>
-            <a:r>
-              <a:rPr sz="810" b="0" lang="ja-JP" altLang="en-US">
-                <a:solidFill>
-                  <a:srgbClr val="626669"/>
-                </a:solidFill>
-                <a:latin typeface="Noto Sans"/>
-                <a:ea typeface="Noto Sans CJK JP"/>
-                <a:cs typeface="Noto Sans"/>
-                <a:hlinkClick r:id="rId2"/>
-              </a:rPr>
-              <a:t>https://github.com/zhangsheng93/cMedQA2</a:t>
-            </a:r>
-          </a:p>
-        </p:txBody>
-      </p:sp>
-    </p:spTree>
-  </p:cSld>
-  <p:clrMapOvr>
-    <a:masterClrMapping/>
-  </p:clrMapOvr>
-</p:sld>
-</file>
-
-<file path=ppt/slides/slide41.xml><?xml version="1.0" encoding="utf-8"?>
 <p:sld xmlns:a="http://schemas.openxmlformats.org/drawingml/2006/main" xmlns:p="http://schemas.openxmlformats.org/presentationml/2006/main" xmlns:r="http://schemas.openxmlformats.org/officeDocument/2006/relationships">
   <p:cSld>
     <p:spTree>
@@ -23296,7 +22936,7 @@
 </p:sld>
 </file>
 
-<file path=ppt/slides/slide42.xml><?xml version="1.0" encoding="utf-8"?>
+<file path=ppt/slides/slide41.xml><?xml version="1.0" encoding="utf-8"?>
 <p:sld xmlns:a="http://schemas.openxmlformats.org/drawingml/2006/main" xmlns:p="http://schemas.openxmlformats.org/presentationml/2006/main" xmlns:r="http://schemas.openxmlformats.org/officeDocument/2006/relationships">
   <p:cSld>
     <p:spTree>
@@ -23770,7 +23410,7 @@
 </p:sld>
 </file>
 
-<file path=ppt/slides/slide43.xml><?xml version="1.0" encoding="utf-8"?>
+<file path=ppt/slides/slide42.xml><?xml version="1.0" encoding="utf-8"?>
 <p:sld xmlns:a="http://schemas.openxmlformats.org/drawingml/2006/main" xmlns:p="http://schemas.openxmlformats.org/presentationml/2006/main" xmlns:r="http://schemas.openxmlformats.org/officeDocument/2006/relationships">
   <p:cSld>
     <p:spTree>
@@ -23884,7 +23524,7 @@
 </p:sld>
 </file>
 
-<file path=ppt/slides/slide44.xml><?xml version="1.0" encoding="utf-8"?>
+<file path=ppt/slides/slide43.xml><?xml version="1.0" encoding="utf-8"?>
 <p:sld xmlns:a="http://schemas.openxmlformats.org/drawingml/2006/main" xmlns:p="http://schemas.openxmlformats.org/presentationml/2006/main" xmlns:r="http://schemas.openxmlformats.org/officeDocument/2006/relationships">
   <p:cSld>
     <p:spTree>
@@ -24310,7 +23950,7 @@
                 <a:ea typeface="Noto Sans CJK JP"/>
                 <a:cs typeface="Noto Sans"/>
               </a:rPr>
-              <a:t>Sheng Zhang et al. · n.d. · GitHub / official data repository</a:t>
+              <a:t>Sheng Zhang et al. · n.d. · GitHub。参照2026-10-18。</a:t>
             </a:r>
           </a:p>
         </p:txBody>
@@ -24420,554 +24060,6 @@
                 <a:hlinkClick r:id="rId3"/>
               </a:rPr>
               <a:t>https://github.com/zhangsheng93/cMedQA2</a:t>
-            </a:r>
-          </a:p>
-        </p:txBody>
-      </p:sp>
-    </p:spTree>
-  </p:cSld>
-  <p:clrMapOvr>
-    <a:masterClrMapping/>
-  </p:clrMapOvr>
-</p:sld>
-</file>
-
-<file path=ppt/slides/slide45.xml><?xml version="1.0" encoding="utf-8"?>
-<p:sld xmlns:a="http://schemas.openxmlformats.org/drawingml/2006/main" xmlns:p="http://schemas.openxmlformats.org/presentationml/2006/main" xmlns:r="http://schemas.openxmlformats.org/officeDocument/2006/relationships">
-  <p:cSld>
-    <p:spTree>
-      <p:nvGrpSpPr>
-        <p:cNvPr id="1" name=""/>
-        <p:cNvGrpSpPr/>
-        <p:nvPr/>
-      </p:nvGrpSpPr>
-      <p:grpSpPr/>
-      <p:sp>
-        <p:nvSpPr>
-          <p:cNvPr id="2" name="Title 1"/>
-          <p:cNvSpPr>
-            <a:spLocks noGrp="1"/>
-          </p:cNvSpPr>
-          <p:nvPr>
-            <p:ph type="title"/>
-          </p:nvPr>
-        </p:nvSpPr>
-        <p:spPr>
-          <a:xfrm>
-            <a:off x="468172" y="650138"/>
-            <a:ext cx="8206740" cy="616305"/>
-          </a:xfrm>
-        </p:spPr>
-        <p:txBody>
-          <a:bodyPr wrap="square" lIns="0" rIns="0" tIns="0" bIns="0">
-            <a:noAutofit/>
-          </a:bodyPr>
-          <a:lstStyle/>
-          <a:p>
-            <a:pPr algn="l">
-              <a:lnSpc>
-                <a:spcPct val="110000"/>
-              </a:lnSpc>
-              <a:buNone/>
-              <a:defRPr sz="2800" b="0">
-                <a:solidFill>
-                  <a:srgbClr val="303437"/>
-                </a:solidFill>
-                <a:latin typeface="Noto Sans"/>
-              </a:defRPr>
-            </a:pPr>
-            <a:r>
-              <a:rPr sz="2800" b="1" lang="ja-JP" altLang="en-US">
-                <a:solidFill>
-                  <a:srgbClr val="303437"/>
-                </a:solidFill>
-                <a:latin typeface="Noto Sans"/>
-                <a:ea typeface="Noto Sans CJK JP"/>
-                <a:cs typeface="Noto Sans"/>
-              </a:rPr>
-              <a:t>参考文献</a:t>
-            </a:r>
-          </a:p>
-        </p:txBody>
-      </p:sp>
-      <p:sp>
-        <p:nvSpPr>
-          <p:cNvPr id="3" name="Title 2"/>
-          <p:cNvSpPr>
-            <a:spLocks noGrp="1"/>
-          </p:cNvSpPr>
-          <p:nvPr>
-            <p:ph type="title" idx="2"/>
-          </p:nvPr>
-        </p:nvSpPr>
-        <p:spPr>
-          <a:xfrm>
-            <a:off x="75895" y="0"/>
-            <a:ext cx="8115300" cy="480060"/>
-          </a:xfrm>
-        </p:spPr>
-        <p:txBody>
-          <a:bodyPr wrap="square" lIns="0" rIns="0" tIns="0" bIns="0" anchor="ctr">
-            <a:noAutofit/>
-          </a:bodyPr>
-          <a:lstStyle/>
-          <a:p>
-            <a:pPr algn="l">
-              <a:lnSpc>
-                <a:spcPct val="110000"/>
-              </a:lnSpc>
-              <a:buNone/>
-              <a:defRPr sz="1400" b="0">
-                <a:solidFill>
-                  <a:srgbClr val="303437"/>
-                </a:solidFill>
-                <a:latin typeface="Noto Sans"/>
-              </a:defRPr>
-            </a:pPr>
-            <a:r>
-              <a:rPr sz="1400" b="1" lang="ja-JP" altLang="en-US">
-                <a:solidFill>
-                  <a:srgbClr val="FFFEF8"/>
-                </a:solidFill>
-                <a:latin typeface="Noto Sans"/>
-                <a:ea typeface="Noto Sans CJK JP"/>
-                <a:cs typeface="Noto Sans"/>
-              </a:rPr>
-              <a:t>Appendix: 3. 参考文献</a:t>
-            </a:r>
-          </a:p>
-        </p:txBody>
-      </p:sp>
-      <p:sp>
-        <p:nvSpPr>
-          <p:cNvPr id="4" name="TextBox 3"/>
-          <p:cNvSpPr txBox="1"/>
-          <p:nvPr/>
-        </p:nvSpPr>
-        <p:spPr>
-          <a:xfrm>
-            <a:off x="548640" y="1344168"/>
-            <a:ext cx="8046720" cy="502920"/>
-          </a:xfrm>
-          <a:prstGeom prst="rect">
-            <a:avLst/>
-          </a:prstGeom>
-          <a:noFill/>
-        </p:spPr>
-        <p:txBody>
-          <a:bodyPr wrap="square" lIns="0" rIns="0" tIns="0" bIns="0">
-            <a:noAutofit/>
-          </a:bodyPr>
-          <a:lstStyle/>
-          <a:p>
-            <a:pPr algn="l">
-              <a:lnSpc>
-                <a:spcPts val="1989"/>
-              </a:lnSpc>
-              <a:spcBef>
-                <a:spcPts val="0"/>
-              </a:spcBef>
-              <a:spcAft>
-                <a:spcPts val="0"/>
-              </a:spcAft>
-              <a:buNone/>
-              <a:defRPr sz="1700" b="0">
-                <a:solidFill>
-                  <a:srgbClr val="303437"/>
-                </a:solidFill>
-                <a:latin typeface="Noto Sans"/>
-              </a:defRPr>
-            </a:pPr>
-            <a:r>
-              <a:rPr sz="1700" b="1" lang="ja-JP" altLang="en-US">
-                <a:solidFill>
-                  <a:srgbClr val="303437"/>
-                </a:solidFill>
-                <a:latin typeface="Noto Sans"/>
-                <a:ea typeface="Noto Sans CJK JP"/>
-                <a:cs typeface="Noto Sans"/>
-              </a:rPr>
-              <a:t>CLEVA: Chinese Language Models EVAluation Platform</a:t>
-            </a:r>
-          </a:p>
-        </p:txBody>
-      </p:sp>
-      <p:sp>
-        <p:nvSpPr>
-          <p:cNvPr id="5" name="TextBox 4"/>
-          <p:cNvSpPr txBox="1"/>
-          <p:nvPr/>
-        </p:nvSpPr>
-        <p:spPr>
-          <a:xfrm>
-            <a:off x="548640" y="1920240"/>
-            <a:ext cx="8046720" cy="384048"/>
-          </a:xfrm>
-          <a:prstGeom prst="rect">
-            <a:avLst/>
-          </a:prstGeom>
-          <a:noFill/>
-        </p:spPr>
-        <p:txBody>
-          <a:bodyPr wrap="square" lIns="0" rIns="0" tIns="0" bIns="0">
-            <a:noAutofit/>
-          </a:bodyPr>
-          <a:lstStyle/>
-          <a:p>
-            <a:pPr algn="l">
-              <a:lnSpc>
-                <a:spcPts val="1462"/>
-              </a:lnSpc>
-              <a:spcBef>
-                <a:spcPts val="0"/>
-              </a:spcBef>
-              <a:spcAft>
-                <a:spcPts val="0"/>
-              </a:spcAft>
-              <a:buNone/>
-              <a:defRPr sz="1250" b="0">
-                <a:solidFill>
-                  <a:srgbClr val="303437"/>
-                </a:solidFill>
-                <a:latin typeface="Noto Sans"/>
-              </a:defRPr>
-            </a:pPr>
-            <a:r>
-              <a:rPr sz="1250" b="0" lang="ja-JP" altLang="en-US">
-                <a:solidFill>
-                  <a:srgbClr val="626669"/>
-                </a:solidFill>
-                <a:latin typeface="Noto Sans"/>
-                <a:ea typeface="Noto Sans CJK JP"/>
-                <a:cs typeface="Noto Sans"/>
-              </a:rPr>
-              <a:t>Li et al. · 2023 · EMNLP System Demonstrations</a:t>
-            </a:r>
-          </a:p>
-        </p:txBody>
-      </p:sp>
-      <p:sp>
-        <p:nvSpPr>
-          <p:cNvPr id="6" name="TextBox 5"/>
-          <p:cNvSpPr txBox="1"/>
-          <p:nvPr/>
-        </p:nvSpPr>
-        <p:spPr>
-          <a:xfrm>
-            <a:off x="548640" y="2276856"/>
-            <a:ext cx="8046720" cy="585216"/>
-          </a:xfrm>
-          <a:prstGeom prst="rect">
-            <a:avLst/>
-          </a:prstGeom>
-          <a:noFill/>
-        </p:spPr>
-        <p:txBody>
-          <a:bodyPr wrap="square" lIns="0" rIns="0" tIns="0" bIns="0">
-            <a:noAutofit/>
-          </a:bodyPr>
-          <a:lstStyle/>
-          <a:p>
-            <a:pPr algn="l">
-              <a:lnSpc>
-                <a:spcPts val="2047"/>
-              </a:lnSpc>
-              <a:spcBef>
-                <a:spcPts val="0"/>
-              </a:spcBef>
-              <a:spcAft>
-                <a:spcPts val="0"/>
-              </a:spcAft>
-              <a:buNone/>
-              <a:defRPr sz="1750" b="0">
-                <a:solidFill>
-                  <a:srgbClr val="303437"/>
-                </a:solidFill>
-                <a:latin typeface="Noto Sans"/>
-              </a:defRPr>
-            </a:pPr>
-            <a:r>
-              <a:rPr sz="1750" b="0" lang="ja-JP" altLang="en-US">
-                <a:solidFill>
-                  <a:srgbClr val="303437"/>
-                </a:solidFill>
-                <a:latin typeface="Noto Sans"/>
-                <a:ea typeface="Noto Sans CJK JP"/>
-                <a:cs typeface="Noto Sans"/>
-              </a:rPr>
-              <a:t>中国語の言語モデルを幅広い課題で評価する枠組み。医療QAのデータとしてcMedQA2を採用する。</a:t>
-            </a:r>
-          </a:p>
-        </p:txBody>
-      </p:sp>
-      <p:sp>
-        <p:nvSpPr>
-          <p:cNvPr id="7" name="TextBox 6"/>
-          <p:cNvSpPr txBox="1"/>
-          <p:nvPr/>
-        </p:nvSpPr>
-        <p:spPr>
-          <a:xfrm>
-            <a:off x="548640" y="2852928"/>
-            <a:ext cx="8046720" cy="246888"/>
-          </a:xfrm>
-          <a:prstGeom prst="rect">
-            <a:avLst/>
-          </a:prstGeom>
-          <a:noFill/>
-        </p:spPr>
-        <p:txBody>
-          <a:bodyPr wrap="square" lIns="0" rIns="0" tIns="0" bIns="0">
-            <a:noAutofit/>
-          </a:bodyPr>
-          <a:lstStyle/>
-          <a:p>
-            <a:pPr algn="l">
-              <a:lnSpc>
-                <a:spcPts val="1345"/>
-              </a:lnSpc>
-              <a:spcBef>
-                <a:spcPts val="0"/>
-              </a:spcBef>
-              <a:spcAft>
-                <a:spcPts val="0"/>
-              </a:spcAft>
-              <a:buNone/>
-              <a:defRPr sz="1150" b="0">
-                <a:solidFill>
-                  <a:srgbClr val="303437"/>
-                </a:solidFill>
-                <a:latin typeface="Noto Sans"/>
-              </a:defRPr>
-            </a:pPr>
-            <a:r>
-              <a:rPr sz="1150" b="0" lang="ja-JP" altLang="en-US">
-                <a:solidFill>
-                  <a:srgbClr val="2166AC"/>
-                </a:solidFill>
-                <a:latin typeface="Noto Sans"/>
-                <a:ea typeface="Noto Sans CJK JP"/>
-                <a:cs typeface="Noto Sans"/>
-                <a:hlinkClick r:id="rId2"/>
-              </a:rPr>
-              <a:t>https://aclanthology.org/2023.emnlp-demo.17/</a:t>
-            </a:r>
-          </a:p>
-        </p:txBody>
-      </p:sp>
-      <p:sp>
-        <p:nvSpPr>
-          <p:cNvPr id="8" name="TextBox 7"/>
-          <p:cNvSpPr txBox="1"/>
-          <p:nvPr/>
-        </p:nvSpPr>
-        <p:spPr>
-          <a:xfrm>
-            <a:off x="548640" y="3209544"/>
-            <a:ext cx="8046720" cy="502920"/>
-          </a:xfrm>
-          <a:prstGeom prst="rect">
-            <a:avLst/>
-          </a:prstGeom>
-          <a:noFill/>
-        </p:spPr>
-        <p:txBody>
-          <a:bodyPr wrap="square" lIns="0" rIns="0" tIns="0" bIns="0">
-            <a:noAutofit/>
-          </a:bodyPr>
-          <a:lstStyle/>
-          <a:p>
-            <a:pPr algn="l">
-              <a:lnSpc>
-                <a:spcPts val="1989"/>
-              </a:lnSpc>
-              <a:spcBef>
-                <a:spcPts val="0"/>
-              </a:spcBef>
-              <a:spcAft>
-                <a:spcPts val="0"/>
-              </a:spcAft>
-              <a:buNone/>
-              <a:defRPr sz="1700" b="0">
-                <a:solidFill>
-                  <a:srgbClr val="303437"/>
-                </a:solidFill>
-                <a:latin typeface="Noto Sans"/>
-              </a:defRPr>
-            </a:pPr>
-            <a:r>
-              <a:rPr sz="1700" b="1" lang="ja-JP" altLang="en-US">
-                <a:solidFill>
-                  <a:srgbClr val="303437"/>
-                </a:solidFill>
-                <a:latin typeface="Noto Sans"/>
-                <a:ea typeface="Noto Sans CJK JP"/>
-                <a:cs typeface="Noto Sans"/>
-              </a:rPr>
-              <a:t>CLEVAClosedBookQuestionAnsweringScenario and Converter</a:t>
-            </a:r>
-          </a:p>
-        </p:txBody>
-      </p:sp>
-      <p:sp>
-        <p:nvSpPr>
-          <p:cNvPr id="9" name="TextBox 8"/>
-          <p:cNvSpPr txBox="1"/>
-          <p:nvPr/>
-        </p:nvSpPr>
-        <p:spPr>
-          <a:xfrm>
-            <a:off x="548640" y="3785615"/>
-            <a:ext cx="8046720" cy="384048"/>
-          </a:xfrm>
-          <a:prstGeom prst="rect">
-            <a:avLst/>
-          </a:prstGeom>
-          <a:noFill/>
-        </p:spPr>
-        <p:txBody>
-          <a:bodyPr wrap="square" lIns="0" rIns="0" tIns="0" bIns="0">
-            <a:noAutofit/>
-          </a:bodyPr>
-          <a:lstStyle/>
-          <a:p>
-            <a:pPr algn="l">
-              <a:lnSpc>
-                <a:spcPts val="1462"/>
-              </a:lnSpc>
-              <a:spcBef>
-                <a:spcPts val="0"/>
-              </a:spcBef>
-              <a:spcAft>
-                <a:spcPts val="0"/>
-              </a:spcAft>
-              <a:buNone/>
-              <a:defRPr sz="1250" b="0">
-                <a:solidFill>
-                  <a:srgbClr val="303437"/>
-                </a:solidFill>
-                <a:latin typeface="Noto Sans"/>
-              </a:defRPr>
-            </a:pPr>
-            <a:r>
-              <a:rPr sz="1250" b="0" lang="ja-JP" altLang="en-US">
-                <a:solidFill>
-                  <a:srgbClr val="626669"/>
-                </a:solidFill>
-                <a:latin typeface="Noto Sans"/>
-                <a:ea typeface="Noto Sans CJK JP"/>
-                <a:cs typeface="Noto Sans"/>
-              </a:rPr>
-              <a:t>Stanford CRFM · HELM v0.4.0</a:t>
-            </a:r>
-          </a:p>
-        </p:txBody>
-      </p:sp>
-      <p:sp>
-        <p:nvSpPr>
-          <p:cNvPr id="10" name="TextBox 9"/>
-          <p:cNvSpPr txBox="1"/>
-          <p:nvPr/>
-        </p:nvSpPr>
-        <p:spPr>
-          <a:xfrm>
-            <a:off x="548640" y="4142231"/>
-            <a:ext cx="8046720" cy="585216"/>
-          </a:xfrm>
-          <a:prstGeom prst="rect">
-            <a:avLst/>
-          </a:prstGeom>
-          <a:noFill/>
-        </p:spPr>
-        <p:txBody>
-          <a:bodyPr wrap="square" lIns="0" rIns="0" tIns="0" bIns="0">
-            <a:noAutofit/>
-          </a:bodyPr>
-          <a:lstStyle/>
-          <a:p>
-            <a:pPr algn="l">
-              <a:lnSpc>
-                <a:spcPts val="2047"/>
-              </a:lnSpc>
-              <a:spcBef>
-                <a:spcPts val="0"/>
-              </a:spcBef>
-              <a:spcAft>
-                <a:spcPts val="0"/>
-              </a:spcAft>
-              <a:buNone/>
-              <a:defRPr sz="1750" b="0">
-                <a:solidFill>
-                  <a:srgbClr val="303437"/>
-                </a:solidFill>
-                <a:latin typeface="Noto Sans"/>
-              </a:defRPr>
-            </a:pPr>
-            <a:r>
-              <a:rPr sz="1750" b="0" lang="ja-JP" altLang="en-US">
-                <a:solidFill>
-                  <a:srgbClr val="303437"/>
-                </a:solidFill>
-                <a:latin typeface="Noto Sans"/>
-                <a:ea typeface="Noto Sans CJK JP"/>
-                <a:cs typeface="Noto Sans"/>
-              </a:rPr>
-              <a:t>医療相談を二択で判定する公開例と、評価データの読み込み方法を定義する。</a:t>
-            </a:r>
-          </a:p>
-        </p:txBody>
-      </p:sp>
-      <p:sp>
-        <p:nvSpPr>
-          <p:cNvPr id="11" name="TextBox 10"/>
-          <p:cNvSpPr txBox="1"/>
-          <p:nvPr/>
-        </p:nvSpPr>
-        <p:spPr>
-          <a:xfrm>
-            <a:off x="548640" y="4718304"/>
-            <a:ext cx="8046720" cy="246888"/>
-          </a:xfrm>
-          <a:prstGeom prst="rect">
-            <a:avLst/>
-          </a:prstGeom>
-          <a:noFill/>
-        </p:spPr>
-        <p:txBody>
-          <a:bodyPr wrap="square" lIns="0" rIns="0" tIns="0" bIns="0">
-            <a:noAutofit/>
-          </a:bodyPr>
-          <a:lstStyle/>
-          <a:p>
-            <a:pPr algn="l">
-              <a:lnSpc>
-                <a:spcPts val="1345"/>
-              </a:lnSpc>
-              <a:spcBef>
-                <a:spcPts val="0"/>
-              </a:spcBef>
-              <a:spcAft>
-                <a:spcPts val="0"/>
-              </a:spcAft>
-              <a:buNone/>
-              <a:defRPr sz="1150" b="0">
-                <a:solidFill>
-                  <a:srgbClr val="303437"/>
-                </a:solidFill>
-                <a:latin typeface="Noto Sans"/>
-              </a:defRPr>
-            </a:pPr>
-            <a:r>
-              <a:rPr sz="1150" b="0" lang="ja-JP" altLang="en-US">
-                <a:solidFill>
-                  <a:srgbClr val="2166AC"/>
-                </a:solidFill>
-                <a:latin typeface="Noto Sans"/>
-                <a:ea typeface="Noto Sans CJK JP"/>
-                <a:cs typeface="Noto Sans"/>
-                <a:hlinkClick r:id="rId3"/>
-              </a:rPr>
-              <a:t>https://github.com/stanford-crfm/helm/blob/v0.4.0/src/helm/benchmark/scenarios/cleva_scenario.py</a:t>
             </a:r>
           </a:p>
         </p:txBody>

</xml_diff>